<commit_message>
grading changes in intro slides
</commit_message>
<xml_diff>
--- a/data.pptx
+++ b/data.pptx
@@ -135,6 +135,22 @@
       </a:defRPr>
     </a:lvl9pPr>
   </p:defaultTextStyle>
+  <p:extLst>
+    <p:ext uri="{EFAFB233-063F-42B5-8137-9DF3F51BA10A}">
+      <p15:sldGuideLst xmlns:p15="http://schemas.microsoft.com/office/powerpoint/2012/main">
+        <p15:guide id="1" orient="horz" pos="2160">
+          <p15:clr>
+            <a:srgbClr val="A4A3A4"/>
+          </p15:clr>
+        </p15:guide>
+        <p15:guide id="2" pos="2880">
+          <p15:clr>
+            <a:srgbClr val="A4A3A4"/>
+          </p15:clr>
+        </p15:guide>
+      </p15:sldGuideLst>
+    </p:ext>
+  </p:extLst>
 </p:presentation>
 </file>
 
@@ -238,7 +254,7 @@
             <a:fld id="{56FF66BB-58F6-4A37-8208-0812DDE6C8EF}" type="datetimeFigureOut">
               <a:rPr lang="el-GR" smtClean="0"/>
               <a:pPr/>
-              <a:t>14/12/2023</a:t>
+              <a:t>18/12/2025</a:t>
             </a:fld>
             <a:endParaRPr lang="el-GR"/>
           </a:p>
@@ -312,6 +328,11 @@
         </p:txBody>
       </p:sp>
     </p:spTree>
+    <p:extLst>
+      <p:ext uri="{BB962C8B-B14F-4D97-AF65-F5344CB8AC3E}">
+        <p14:creationId xmlns:p14="http://schemas.microsoft.com/office/powerpoint/2010/main" val="1"/>
+      </p:ext>
+    </p:extLst>
   </p:cSld>
   <p:clrMap bg1="lt1" tx1="dk1" bg2="lt2" tx2="dk2" accent1="accent1" accent2="accent2" accent3="accent3" accent4="accent4" accent5="accent5" accent6="accent6" hlink="hlink" folHlink="folHlink"/>
 </p:handoutMaster>
@@ -400,7 +421,7 @@
             <a:fld id="{DC17DF70-03C8-4BDB-82BF-9C076E474B74}" type="datetimeFigureOut">
               <a:rPr lang="el-GR" smtClean="0"/>
               <a:pPr/>
-              <a:t>14/12/2023</a:t>
+              <a:t>18/12/2025</a:t>
             </a:fld>
             <a:endParaRPr lang="el-GR"/>
           </a:p>
@@ -466,35 +487,35 @@
           <a:p>
             <a:pPr lvl="0"/>
             <a:r>
-              <a:rPr lang="en-US" smtClean="0"/>
+              <a:rPr lang="en-US"/>
               <a:t>Click to edit Master text styles</a:t>
             </a:r>
           </a:p>
           <a:p>
             <a:pPr lvl="1"/>
             <a:r>
-              <a:rPr lang="en-US" smtClean="0"/>
+              <a:rPr lang="en-US"/>
               <a:t>Second level</a:t>
             </a:r>
           </a:p>
           <a:p>
             <a:pPr lvl="2"/>
             <a:r>
-              <a:rPr lang="en-US" smtClean="0"/>
+              <a:rPr lang="en-US"/>
               <a:t>Third level</a:t>
             </a:r>
           </a:p>
           <a:p>
             <a:pPr lvl="3"/>
             <a:r>
-              <a:rPr lang="en-US" smtClean="0"/>
+              <a:rPr lang="en-US"/>
               <a:t>Fourth level</a:t>
             </a:r>
           </a:p>
           <a:p>
             <a:pPr lvl="4"/>
             <a:r>
-              <a:rPr lang="en-US" smtClean="0"/>
+              <a:rPr lang="en-US"/>
               <a:t>Fifth level</a:t>
             </a:r>
             <a:endParaRPr lang="el-GR"/>
@@ -713,15 +734,15 @@
           <a:lstStyle/>
           <a:p>
             <a:r>
-              <a:rPr lang="en-US" dirty="0" err="1" smtClean="0"/>
+              <a:rPr lang="en-US" dirty="0" err="1"/>
               <a:t>Typecode</a:t>
             </a:r>
             <a:r>
-              <a:rPr lang="en-US" dirty="0" smtClean="0"/>
+              <a:rPr lang="en-US" dirty="0"/>
               <a:t> is a</a:t>
             </a:r>
             <a:r>
-              <a:rPr lang="en-US" baseline="0" dirty="0" smtClean="0"/>
+              <a:rPr lang="en-US" baseline="0" dirty="0"/>
               <a:t> class attribute that we use to distinguish different subsets of the class objects</a:t>
             </a:r>
             <a:endParaRPr lang="en-US" dirty="0"/>
@@ -807,15 +828,15 @@
           <a:lstStyle/>
           <a:p>
             <a:r>
-              <a:rPr lang="en-US" dirty="0" smtClean="0"/>
+              <a:rPr lang="en-US" dirty="0"/>
               <a:t>Clump</a:t>
             </a:r>
             <a:r>
-              <a:rPr lang="en-US" baseline="0" dirty="0" smtClean="0"/>
+              <a:rPr lang="en-US" baseline="0" dirty="0"/>
               <a:t> = </a:t>
             </a:r>
             <a:r>
-              <a:rPr lang="el-GR" baseline="0" dirty="0" smtClean="0"/>
+              <a:rPr lang="el-GR" baseline="0" dirty="0"/>
               <a:t>συστάδα</a:t>
             </a:r>
             <a:endParaRPr lang="en-US" dirty="0"/>
@@ -901,19 +922,19 @@
           <a:lstStyle/>
           <a:p>
             <a:r>
-              <a:rPr lang="en-US" dirty="0" smtClean="0"/>
+              <a:rPr lang="en-US" dirty="0"/>
               <a:t>Give example with various</a:t>
             </a:r>
             <a:r>
-              <a:rPr lang="en-US" baseline="0" dirty="0" smtClean="0"/>
+              <a:rPr lang="en-US" baseline="0" dirty="0"/>
               <a:t> </a:t>
             </a:r>
             <a:r>
-              <a:rPr lang="en-US" baseline="0" dirty="0" err="1" smtClean="0"/>
+              <a:rPr lang="en-US" baseline="0" dirty="0" err="1"/>
               <a:t>custore</a:t>
             </a:r>
             <a:r>
-              <a:rPr lang="en-US" baseline="0" dirty="0" smtClean="0"/>
+              <a:rPr lang="en-US" baseline="0" dirty="0"/>
               <a:t> related fields</a:t>
             </a:r>
             <a:endParaRPr lang="en-US" dirty="0"/>
@@ -1081,18 +1102,17 @@
           <a:lstStyle/>
           <a:p>
             <a:r>
-              <a:rPr lang="en-US" dirty="0" smtClean="0"/>
+              <a:rPr lang="en-US" dirty="0"/>
               <a:t>No matter the </a:t>
             </a:r>
             <a:r>
-              <a:rPr lang="en-US" dirty="0" err="1" smtClean="0"/>
+              <a:rPr lang="en-US" dirty="0" err="1"/>
               <a:t>typecode</a:t>
             </a:r>
             <a:r>
-              <a:rPr lang="en-US" dirty="0" smtClean="0"/>
+              <a:rPr lang="en-US" dirty="0"/>
               <a:t> the behavior is the same</a:t>
             </a:r>
-            <a:endParaRPr lang="en-US" dirty="0"/>
           </a:p>
         </p:txBody>
       </p:sp>
@@ -1178,33 +1198,33 @@
               <a:buAutoNum type="arabicParenR"/>
             </a:pPr>
             <a:r>
-              <a:rPr lang="en-US" dirty="0" smtClean="0"/>
+              <a:rPr lang="en-US" dirty="0"/>
               <a:t>The behavior</a:t>
             </a:r>
             <a:r>
-              <a:rPr lang="en-US" baseline="0" dirty="0" smtClean="0"/>
+              <a:rPr lang="en-US" baseline="0" dirty="0"/>
               <a:t> varies depending on the </a:t>
             </a:r>
             <a:r>
-              <a:rPr lang="en-US" baseline="0" dirty="0" err="1" smtClean="0"/>
+              <a:rPr lang="en-US" baseline="0" dirty="0" err="1"/>
               <a:t>typecode</a:t>
             </a:r>
-            <a:endParaRPr lang="en-US" baseline="0" dirty="0" smtClean="0"/>
+            <a:endParaRPr lang="en-US" baseline="0" dirty="0"/>
           </a:p>
           <a:p>
             <a:pPr marL="235277" indent="-235277">
               <a:buAutoNum type="arabicParenR"/>
             </a:pPr>
             <a:r>
-              <a:rPr lang="en-US" baseline="0" dirty="0" smtClean="0"/>
+              <a:rPr lang="en-US" baseline="0" dirty="0"/>
               <a:t>The </a:t>
             </a:r>
             <a:r>
-              <a:rPr lang="en-US" baseline="0" dirty="0" err="1" smtClean="0"/>
+              <a:rPr lang="en-US" baseline="0" dirty="0" err="1"/>
               <a:t>typecode</a:t>
             </a:r>
             <a:r>
-              <a:rPr lang="en-US" baseline="0" dirty="0" smtClean="0"/>
+              <a:rPr lang="en-US" baseline="0" dirty="0"/>
               <a:t> is immutable after the object creation</a:t>
             </a:r>
           </a:p>
@@ -1212,12 +1232,12 @@
             <a:pPr marL="235277" indent="-235277">
               <a:buAutoNum type="arabicParenR"/>
             </a:pPr>
-            <a:endParaRPr lang="en-US" baseline="0" dirty="0" smtClean="0"/>
+            <a:endParaRPr lang="en-US" baseline="0" dirty="0"/>
           </a:p>
           <a:p>
             <a:pPr marL="235277" indent="-235277"/>
             <a:r>
-              <a:rPr lang="en-US" baseline="0" dirty="0" smtClean="0"/>
+              <a:rPr lang="en-US" baseline="0" dirty="0"/>
               <a:t>Make the varying parts abstract and put the concrete variations into subclasses </a:t>
             </a:r>
             <a:endParaRPr lang="en-US" dirty="0"/>
@@ -1306,33 +1326,33 @@
               <a:buAutoNum type="arabicParenR"/>
             </a:pPr>
             <a:r>
-              <a:rPr lang="en-US" dirty="0" smtClean="0"/>
+              <a:rPr lang="en-US" dirty="0"/>
               <a:t>The behavior</a:t>
             </a:r>
             <a:r>
-              <a:rPr lang="en-US" baseline="0" dirty="0" smtClean="0"/>
+              <a:rPr lang="en-US" baseline="0" dirty="0"/>
               <a:t> varies depending on the </a:t>
             </a:r>
             <a:r>
-              <a:rPr lang="en-US" baseline="0" dirty="0" err="1" smtClean="0"/>
+              <a:rPr lang="en-US" baseline="0" dirty="0" err="1"/>
               <a:t>typecode</a:t>
             </a:r>
-            <a:endParaRPr lang="en-US" baseline="0" dirty="0" smtClean="0"/>
+            <a:endParaRPr lang="en-US" baseline="0" dirty="0"/>
           </a:p>
           <a:p>
             <a:pPr marL="235277" indent="-235277">
               <a:buAutoNum type="arabicParenR"/>
             </a:pPr>
             <a:r>
-              <a:rPr lang="en-US" baseline="0" dirty="0" smtClean="0"/>
+              <a:rPr lang="en-US" baseline="0" dirty="0"/>
               <a:t>The </a:t>
             </a:r>
             <a:r>
-              <a:rPr lang="en-US" baseline="0" dirty="0" err="1" smtClean="0"/>
+              <a:rPr lang="en-US" baseline="0" dirty="0" err="1"/>
               <a:t>typecode</a:t>
             </a:r>
             <a:r>
-              <a:rPr lang="en-US" baseline="0" dirty="0" smtClean="0"/>
+              <a:rPr lang="en-US" baseline="0" dirty="0"/>
               <a:t> is immutable after the object creation</a:t>
             </a:r>
           </a:p>
@@ -1340,12 +1360,12 @@
             <a:pPr marL="235277" indent="-235277">
               <a:buAutoNum type="arabicParenR"/>
             </a:pPr>
-            <a:endParaRPr lang="en-US" baseline="0" dirty="0" smtClean="0"/>
+            <a:endParaRPr lang="en-US" baseline="0" dirty="0"/>
           </a:p>
           <a:p>
             <a:pPr marL="235277" indent="-235277"/>
             <a:r>
-              <a:rPr lang="en-US" baseline="0" dirty="0" smtClean="0"/>
+              <a:rPr lang="en-US" baseline="0" dirty="0"/>
               <a:t>Make the varying parts abstract and put the concrete variations into subclasses </a:t>
             </a:r>
             <a:endParaRPr lang="en-US" dirty="0"/>
@@ -1431,19 +1451,19 @@
           <a:lstStyle/>
           <a:p>
             <a:r>
-              <a:rPr lang="en-US" dirty="0" smtClean="0"/>
+              <a:rPr lang="en-US" dirty="0"/>
               <a:t>If the </a:t>
             </a:r>
             <a:r>
-              <a:rPr lang="en-US" dirty="0" err="1" smtClean="0"/>
+              <a:rPr lang="en-US" dirty="0" err="1"/>
               <a:t>typecode</a:t>
             </a:r>
             <a:r>
-              <a:rPr lang="en-US" dirty="0" smtClean="0"/>
+              <a:rPr lang="en-US" dirty="0"/>
               <a:t> value</a:t>
             </a:r>
             <a:r>
-              <a:rPr lang="en-US" baseline="0" dirty="0" smtClean="0"/>
+              <a:rPr lang="en-US" baseline="0" dirty="0"/>
               <a:t> changes and the behavior of the class objects changes accordingly you need to be able to change the behavior of the class objects dynamically </a:t>
             </a:r>
             <a:endParaRPr lang="en-US" dirty="0"/>
@@ -1532,11 +1552,11 @@
               <a:buNone/>
             </a:pPr>
             <a:r>
-              <a:rPr lang="en-US" dirty="0" smtClean="0"/>
+              <a:rPr lang="en-US" dirty="0"/>
               <a:t>!! You</a:t>
             </a:r>
             <a:r>
-              <a:rPr lang="en-US" baseline="0" dirty="0" smtClean="0"/>
+              <a:rPr lang="en-US" baseline="0" dirty="0"/>
               <a:t> should explain Strategy pattern first !!!</a:t>
             </a:r>
           </a:p>
@@ -1544,44 +1564,40 @@
             <a:pPr marL="235277" indent="-235277">
               <a:buNone/>
             </a:pPr>
-            <a:endParaRPr lang="el-GR" dirty="0" smtClean="0"/>
+            <a:endParaRPr lang="el-GR" dirty="0"/>
           </a:p>
           <a:p>
             <a:pPr marL="235277" indent="-235277">
               <a:buAutoNum type="arabicParenR"/>
             </a:pPr>
             <a:r>
-              <a:rPr lang="en-US" dirty="0" smtClean="0"/>
-              <a:t>The </a:t>
-            </a:r>
-            <a:r>
-              <a:rPr lang="en-US" dirty="0" smtClean="0"/>
-              <a:t>behavior</a:t>
-            </a:r>
-            <a:r>
-              <a:rPr lang="en-US" baseline="0" dirty="0" smtClean="0"/>
+              <a:rPr lang="en-US" dirty="0"/>
+              <a:t>The behavior</a:t>
+            </a:r>
+            <a:r>
+              <a:rPr lang="en-US" baseline="0" dirty="0"/>
               <a:t> varies depending on the </a:t>
             </a:r>
             <a:r>
-              <a:rPr lang="en-US" baseline="0" dirty="0" err="1" smtClean="0"/>
+              <a:rPr lang="en-US" baseline="0" dirty="0" err="1"/>
               <a:t>typecode</a:t>
             </a:r>
-            <a:endParaRPr lang="en-US" baseline="0" dirty="0" smtClean="0"/>
+            <a:endParaRPr lang="en-US" baseline="0" dirty="0"/>
           </a:p>
           <a:p>
             <a:pPr marL="235277" indent="-235277">
               <a:buAutoNum type="arabicParenR"/>
             </a:pPr>
             <a:r>
-              <a:rPr lang="en-US" baseline="0" dirty="0" smtClean="0"/>
+              <a:rPr lang="en-US" baseline="0" dirty="0"/>
               <a:t>The </a:t>
             </a:r>
             <a:r>
-              <a:rPr lang="en-US" baseline="0" dirty="0" err="1" smtClean="0"/>
+              <a:rPr lang="en-US" baseline="0" dirty="0" err="1"/>
               <a:t>typecode</a:t>
             </a:r>
             <a:r>
-              <a:rPr lang="en-US" baseline="0" dirty="0" smtClean="0"/>
+              <a:rPr lang="en-US" baseline="0" dirty="0"/>
               <a:t> can change after the object creation</a:t>
             </a:r>
           </a:p>
@@ -1590,15 +1606,15 @@
               <a:buAutoNum type="arabicParenR"/>
             </a:pPr>
             <a:r>
-              <a:rPr lang="en-US" baseline="0" dirty="0" smtClean="0"/>
+              <a:rPr lang="en-US" baseline="0" dirty="0"/>
               <a:t>The </a:t>
             </a:r>
             <a:r>
-              <a:rPr lang="en-US" baseline="0" dirty="0" err="1" smtClean="0"/>
+              <a:rPr lang="en-US" baseline="0" dirty="0" err="1"/>
               <a:t>typecode</a:t>
             </a:r>
             <a:r>
-              <a:rPr lang="en-US" baseline="0" dirty="0" smtClean="0"/>
+              <a:rPr lang="en-US" baseline="0" dirty="0"/>
               <a:t> is changed from the clients of the object -&gt; Strategy</a:t>
             </a:r>
           </a:p>
@@ -1607,19 +1623,19 @@
               <a:buAutoNum type="arabicParenR"/>
             </a:pPr>
             <a:r>
-              <a:rPr lang="en-US" baseline="0" dirty="0" smtClean="0"/>
+              <a:rPr lang="en-US" baseline="0" dirty="0"/>
               <a:t>The </a:t>
             </a:r>
             <a:r>
-              <a:rPr lang="en-US" baseline="0" dirty="0" err="1" smtClean="0"/>
+              <a:rPr lang="en-US" baseline="0" dirty="0" err="1"/>
               <a:t>typecode</a:t>
             </a:r>
             <a:r>
-              <a:rPr lang="en-US" baseline="0" dirty="0" smtClean="0"/>
+              <a:rPr lang="en-US" baseline="0" dirty="0"/>
               <a:t> is changed from the object itself depending on its current </a:t>
             </a:r>
             <a:r>
-              <a:rPr lang="en-US" b="1" baseline="0" dirty="0" smtClean="0">
+              <a:rPr lang="en-US" b="1" baseline="0" dirty="0">
                 <a:solidFill>
                   <a:srgbClr val="FF0000"/>
                 </a:solidFill>
@@ -1627,7 +1643,7 @@
               <a:t>state</a:t>
             </a:r>
             <a:r>
-              <a:rPr lang="en-US" baseline="0" dirty="0" smtClean="0"/>
+              <a:rPr lang="en-US" baseline="0" dirty="0"/>
               <a:t>  -&gt; State</a:t>
             </a:r>
           </a:p>
@@ -1635,63 +1651,63 @@
             <a:pPr marL="705830" lvl="1" indent="-235277">
               <a:buAutoNum type="arabicParenR"/>
             </a:pPr>
-            <a:endParaRPr lang="en-US" baseline="0" dirty="0" smtClean="0"/>
+            <a:endParaRPr lang="en-US" baseline="0" dirty="0"/>
           </a:p>
           <a:p>
             <a:pPr marL="705830" lvl="1" indent="-235277"/>
-            <a:endParaRPr lang="en-US" baseline="0" dirty="0" smtClean="0"/>
+            <a:endParaRPr lang="en-US" baseline="0" dirty="0"/>
           </a:p>
           <a:p>
             <a:pPr marL="705830" lvl="1" indent="-235277"/>
             <a:r>
-              <a:rPr lang="en-US" baseline="0" dirty="0" smtClean="0"/>
+              <a:rPr lang="en-US" baseline="0" dirty="0"/>
               <a:t>Create an new Hierarchy and move the varying parts there</a:t>
             </a:r>
           </a:p>
           <a:p>
             <a:pPr marL="705830" lvl="1" indent="-235277"/>
-            <a:endParaRPr lang="en-US" baseline="0" dirty="0" smtClean="0"/>
+            <a:endParaRPr lang="en-US" baseline="0" dirty="0"/>
           </a:p>
           <a:p>
             <a:pPr marL="705830" lvl="1" indent="-235277"/>
             <a:r>
-              <a:rPr lang="en-US" baseline="0" dirty="0" smtClean="0"/>
+              <a:rPr lang="en-US" baseline="0" dirty="0"/>
               <a:t>Base class has abstract </a:t>
             </a:r>
             <a:r>
-              <a:rPr lang="en-US" baseline="0" dirty="0" err="1" smtClean="0"/>
+              <a:rPr lang="en-US" baseline="0" dirty="0" err="1"/>
               <a:t>defs</a:t>
             </a:r>
             <a:r>
-              <a:rPr lang="en-US" baseline="0" dirty="0" smtClean="0"/>
+              <a:rPr lang="en-US" baseline="0" dirty="0"/>
               <a:t> of the varying parts </a:t>
             </a:r>
           </a:p>
           <a:p>
             <a:pPr marL="705830" lvl="1" indent="-235277"/>
             <a:r>
-              <a:rPr lang="en-US" baseline="0" dirty="0" smtClean="0"/>
+              <a:rPr lang="en-US" baseline="0" dirty="0"/>
               <a:t>Subclasses have the concrete variations</a:t>
             </a:r>
           </a:p>
           <a:p>
             <a:pPr marL="705830" lvl="1" indent="-235277"/>
-            <a:endParaRPr lang="en-US" baseline="0" dirty="0" smtClean="0"/>
+            <a:endParaRPr lang="en-US" baseline="0" dirty="0"/>
           </a:p>
           <a:p>
             <a:pPr marL="705830" lvl="1" indent="-235277"/>
             <a:r>
-              <a:rPr lang="en-US" baseline="0" dirty="0" smtClean="0"/>
+              <a:rPr lang="en-US" baseline="0" dirty="0"/>
               <a:t>Original class delegates calls to the varying parts to the encapsulated object</a:t>
             </a:r>
           </a:p>
           <a:p>
             <a:pPr marL="705830" lvl="1" indent="-235277"/>
-            <a:endParaRPr lang="en-US" baseline="0" dirty="0" smtClean="0"/>
+            <a:endParaRPr lang="en-US" baseline="0" dirty="0"/>
           </a:p>
           <a:p>
             <a:pPr marL="705830" lvl="1" indent="-235277"/>
-            <a:endParaRPr lang="en-US" dirty="0" smtClean="0"/>
+            <a:endParaRPr lang="en-US" dirty="0"/>
           </a:p>
           <a:p>
             <a:endParaRPr lang="en-US" dirty="0"/>
@@ -1780,33 +1796,33 @@
               <a:buAutoNum type="arabicParenR"/>
             </a:pPr>
             <a:r>
-              <a:rPr lang="en-US" dirty="0" smtClean="0"/>
+              <a:rPr lang="en-US" dirty="0"/>
               <a:t>The behavior</a:t>
             </a:r>
             <a:r>
-              <a:rPr lang="en-US" baseline="0" dirty="0" smtClean="0"/>
+              <a:rPr lang="en-US" baseline="0" dirty="0"/>
               <a:t> varies depending on the </a:t>
             </a:r>
             <a:r>
-              <a:rPr lang="en-US" baseline="0" dirty="0" err="1" smtClean="0"/>
+              <a:rPr lang="en-US" baseline="0" dirty="0" err="1"/>
               <a:t>typecode</a:t>
             </a:r>
-            <a:endParaRPr lang="en-US" baseline="0" dirty="0" smtClean="0"/>
+            <a:endParaRPr lang="en-US" baseline="0" dirty="0"/>
           </a:p>
           <a:p>
             <a:pPr marL="235277" indent="-235277">
               <a:buAutoNum type="arabicParenR"/>
             </a:pPr>
             <a:r>
-              <a:rPr lang="en-US" baseline="0" dirty="0" smtClean="0"/>
+              <a:rPr lang="en-US" baseline="0" dirty="0"/>
               <a:t>The </a:t>
             </a:r>
             <a:r>
-              <a:rPr lang="en-US" baseline="0" dirty="0" err="1" smtClean="0"/>
+              <a:rPr lang="en-US" baseline="0" dirty="0" err="1"/>
               <a:t>typecode</a:t>
             </a:r>
             <a:r>
-              <a:rPr lang="en-US" baseline="0" dirty="0" smtClean="0"/>
+              <a:rPr lang="en-US" baseline="0" dirty="0"/>
               <a:t> can change after the object creation</a:t>
             </a:r>
           </a:p>
@@ -1815,15 +1831,15 @@
               <a:buAutoNum type="arabicParenR"/>
             </a:pPr>
             <a:r>
-              <a:rPr lang="en-US" baseline="0" dirty="0" smtClean="0"/>
+              <a:rPr lang="en-US" baseline="0" dirty="0"/>
               <a:t>The </a:t>
             </a:r>
             <a:r>
-              <a:rPr lang="en-US" baseline="0" dirty="0" err="1" smtClean="0"/>
+              <a:rPr lang="en-US" baseline="0" dirty="0" err="1"/>
               <a:t>typecode</a:t>
             </a:r>
             <a:r>
-              <a:rPr lang="en-US" baseline="0" dirty="0" smtClean="0"/>
+              <a:rPr lang="en-US" baseline="0" dirty="0"/>
               <a:t> is changed from the clients of the object -&gt; Strategy</a:t>
             </a:r>
           </a:p>
@@ -1832,19 +1848,19 @@
               <a:buAutoNum type="arabicParenR"/>
             </a:pPr>
             <a:r>
-              <a:rPr lang="en-US" baseline="0" dirty="0" smtClean="0"/>
+              <a:rPr lang="en-US" baseline="0" dirty="0"/>
               <a:t>The </a:t>
             </a:r>
             <a:r>
-              <a:rPr lang="en-US" baseline="0" dirty="0" err="1" smtClean="0"/>
+              <a:rPr lang="en-US" baseline="0" dirty="0" err="1"/>
               <a:t>typecode</a:t>
             </a:r>
             <a:r>
-              <a:rPr lang="en-US" baseline="0" dirty="0" smtClean="0"/>
+              <a:rPr lang="en-US" baseline="0" dirty="0"/>
               <a:t> is changed from the object itself depending on its current </a:t>
             </a:r>
             <a:r>
-              <a:rPr lang="en-US" b="1" baseline="0" dirty="0" smtClean="0">
+              <a:rPr lang="en-US" b="1" baseline="0" dirty="0">
                 <a:solidFill>
                   <a:srgbClr val="FF0000"/>
                 </a:solidFill>
@@ -1852,7 +1868,7 @@
               <a:t>state</a:t>
             </a:r>
             <a:r>
-              <a:rPr lang="en-US" baseline="0" dirty="0" smtClean="0"/>
+              <a:rPr lang="en-US" baseline="0" dirty="0"/>
               <a:t>  -&gt; State</a:t>
             </a:r>
           </a:p>
@@ -1860,63 +1876,63 @@
             <a:pPr marL="705830" lvl="1" indent="-235277">
               <a:buAutoNum type="arabicParenR"/>
             </a:pPr>
-            <a:endParaRPr lang="en-US" baseline="0" dirty="0" smtClean="0"/>
+            <a:endParaRPr lang="en-US" baseline="0" dirty="0"/>
           </a:p>
           <a:p>
             <a:pPr marL="705830" lvl="1" indent="-235277"/>
-            <a:endParaRPr lang="en-US" baseline="0" dirty="0" smtClean="0"/>
+            <a:endParaRPr lang="en-US" baseline="0" dirty="0"/>
           </a:p>
           <a:p>
             <a:pPr marL="705830" lvl="1" indent="-235277"/>
             <a:r>
-              <a:rPr lang="en-US" baseline="0" dirty="0" smtClean="0"/>
+              <a:rPr lang="en-US" baseline="0" dirty="0"/>
               <a:t>Create an new Hierarchy and move the varying parts there</a:t>
             </a:r>
           </a:p>
           <a:p>
             <a:pPr marL="705830" lvl="1" indent="-235277"/>
-            <a:endParaRPr lang="en-US" baseline="0" dirty="0" smtClean="0"/>
+            <a:endParaRPr lang="en-US" baseline="0" dirty="0"/>
           </a:p>
           <a:p>
             <a:pPr marL="705830" lvl="1" indent="-235277"/>
             <a:r>
-              <a:rPr lang="en-US" baseline="0" dirty="0" smtClean="0"/>
+              <a:rPr lang="en-US" baseline="0" dirty="0"/>
               <a:t>Base class has abstract </a:t>
             </a:r>
             <a:r>
-              <a:rPr lang="en-US" baseline="0" dirty="0" err="1" smtClean="0"/>
+              <a:rPr lang="en-US" baseline="0" dirty="0" err="1"/>
               <a:t>defs</a:t>
             </a:r>
             <a:r>
-              <a:rPr lang="en-US" baseline="0" dirty="0" smtClean="0"/>
+              <a:rPr lang="en-US" baseline="0" dirty="0"/>
               <a:t> of the varying parts </a:t>
             </a:r>
           </a:p>
           <a:p>
             <a:pPr marL="705830" lvl="1" indent="-235277"/>
             <a:r>
-              <a:rPr lang="en-US" baseline="0" dirty="0" smtClean="0"/>
+              <a:rPr lang="en-US" baseline="0" dirty="0"/>
               <a:t>Subclasses have the concrete variations</a:t>
             </a:r>
           </a:p>
           <a:p>
             <a:pPr marL="705830" lvl="1" indent="-235277"/>
-            <a:endParaRPr lang="en-US" baseline="0" dirty="0" smtClean="0"/>
+            <a:endParaRPr lang="en-US" baseline="0" dirty="0"/>
           </a:p>
           <a:p>
             <a:pPr marL="705830" lvl="1" indent="-235277"/>
             <a:r>
-              <a:rPr lang="en-US" baseline="0" dirty="0" smtClean="0"/>
+              <a:rPr lang="en-US" baseline="0" dirty="0"/>
               <a:t>Original class delegates calls to the varying parts to the encapsulated object</a:t>
             </a:r>
           </a:p>
           <a:p>
             <a:pPr marL="705830" lvl="1" indent="-235277"/>
-            <a:endParaRPr lang="en-US" baseline="0" dirty="0" smtClean="0"/>
+            <a:endParaRPr lang="en-US" baseline="0" dirty="0"/>
           </a:p>
           <a:p>
             <a:pPr marL="705830" lvl="1" indent="-235277"/>
-            <a:endParaRPr lang="en-US" dirty="0" smtClean="0"/>
+            <a:endParaRPr lang="en-US" dirty="0"/>
           </a:p>
           <a:p>
             <a:endParaRPr lang="en-US" dirty="0"/>
@@ -2001,10 +2017,9 @@
           </a:lstStyle>
           <a:p>
             <a:r>
-              <a:rPr kumimoji="0" lang="en-US" smtClean="0"/>
+              <a:rPr kumimoji="0" lang="en-US"/>
               <a:t>Click to edit Master title style</a:t>
             </a:r>
-            <a:endParaRPr kumimoji="0" lang="en-US"/>
           </a:p>
         </p:txBody>
       </p:sp>
@@ -2065,10 +2080,9 @@
           </a:lstStyle>
           <a:p>
             <a:r>
-              <a:rPr kumimoji="0" lang="en-US" smtClean="0"/>
+              <a:rPr kumimoji="0" lang="en-US"/>
               <a:t>Click to edit Master subtitle style</a:t>
             </a:r>
-            <a:endParaRPr kumimoji="0" lang="en-US"/>
           </a:p>
         </p:txBody>
       </p:sp>
@@ -2099,7 +2113,7 @@
             <a:fld id="{1D8BD707-D9CF-40AE-B4C6-C98DA3205C09}" type="datetimeFigureOut">
               <a:rPr lang="en-US" smtClean="0"/>
               <a:pPr/>
-              <a:t>12/14/2023</a:t>
+              <a:t>12/18/2025</a:t>
             </a:fld>
             <a:endParaRPr lang="en-US"/>
           </a:p>
@@ -2383,10 +2397,9 @@
           <a:lstStyle/>
           <a:p>
             <a:r>
-              <a:rPr kumimoji="0" lang="en-US" smtClean="0"/>
+              <a:rPr kumimoji="0" lang="en-US"/>
               <a:t>Click to edit Master title style</a:t>
             </a:r>
-            <a:endParaRPr kumimoji="0" lang="en-US"/>
           </a:p>
         </p:txBody>
       </p:sp>
@@ -2407,35 +2420,35 @@
           <a:p>
             <a:pPr lvl="0" eaLnBrk="1" latinLnBrk="0" hangingPunct="1"/>
             <a:r>
-              <a:rPr lang="en-US" smtClean="0"/>
+              <a:rPr lang="en-US"/>
               <a:t>Click to edit Master text styles</a:t>
             </a:r>
           </a:p>
           <a:p>
             <a:pPr lvl="1" eaLnBrk="1" latinLnBrk="0" hangingPunct="1"/>
             <a:r>
-              <a:rPr lang="en-US" smtClean="0"/>
+              <a:rPr lang="en-US"/>
               <a:t>Second level</a:t>
             </a:r>
           </a:p>
           <a:p>
             <a:pPr lvl="2" eaLnBrk="1" latinLnBrk="0" hangingPunct="1"/>
             <a:r>
-              <a:rPr lang="en-US" smtClean="0"/>
+              <a:rPr lang="en-US"/>
               <a:t>Third level</a:t>
             </a:r>
           </a:p>
           <a:p>
             <a:pPr lvl="3" eaLnBrk="1" latinLnBrk="0" hangingPunct="1"/>
             <a:r>
-              <a:rPr lang="en-US" smtClean="0"/>
+              <a:rPr lang="en-US"/>
               <a:t>Fourth level</a:t>
             </a:r>
           </a:p>
           <a:p>
             <a:pPr lvl="4" eaLnBrk="1" latinLnBrk="0" hangingPunct="1"/>
             <a:r>
-              <a:rPr lang="en-US" smtClean="0"/>
+              <a:rPr lang="en-US"/>
               <a:t>Fifth level</a:t>
             </a:r>
             <a:endParaRPr kumimoji="0" lang="en-US"/>
@@ -2460,7 +2473,7 @@
             <a:fld id="{1D8BD707-D9CF-40AE-B4C6-C98DA3205C09}" type="datetimeFigureOut">
               <a:rPr lang="en-US" smtClean="0"/>
               <a:pPr/>
-              <a:t>12/14/2023</a:t>
+              <a:t>12/18/2025</a:t>
             </a:fld>
             <a:endParaRPr lang="en-US"/>
           </a:p>
@@ -2555,10 +2568,9 @@
           <a:lstStyle/>
           <a:p>
             <a:r>
-              <a:rPr kumimoji="0" lang="en-US" smtClean="0"/>
+              <a:rPr kumimoji="0" lang="en-US"/>
               <a:t>Click to edit Master title style</a:t>
             </a:r>
-            <a:endParaRPr kumimoji="0" lang="en-US"/>
           </a:p>
         </p:txBody>
       </p:sp>
@@ -2584,35 +2596,35 @@
           <a:p>
             <a:pPr lvl="0" eaLnBrk="1" latinLnBrk="0" hangingPunct="1"/>
             <a:r>
-              <a:rPr lang="en-US" smtClean="0"/>
+              <a:rPr lang="en-US"/>
               <a:t>Click to edit Master text styles</a:t>
             </a:r>
           </a:p>
           <a:p>
             <a:pPr lvl="1" eaLnBrk="1" latinLnBrk="0" hangingPunct="1"/>
             <a:r>
-              <a:rPr lang="en-US" smtClean="0"/>
+              <a:rPr lang="en-US"/>
               <a:t>Second level</a:t>
             </a:r>
           </a:p>
           <a:p>
             <a:pPr lvl="2" eaLnBrk="1" latinLnBrk="0" hangingPunct="1"/>
             <a:r>
-              <a:rPr lang="en-US" smtClean="0"/>
+              <a:rPr lang="en-US"/>
               <a:t>Third level</a:t>
             </a:r>
           </a:p>
           <a:p>
             <a:pPr lvl="3" eaLnBrk="1" latinLnBrk="0" hangingPunct="1"/>
             <a:r>
-              <a:rPr lang="en-US" smtClean="0"/>
+              <a:rPr lang="en-US"/>
               <a:t>Fourth level</a:t>
             </a:r>
           </a:p>
           <a:p>
             <a:pPr lvl="4" eaLnBrk="1" latinLnBrk="0" hangingPunct="1"/>
             <a:r>
-              <a:rPr lang="en-US" smtClean="0"/>
+              <a:rPr lang="en-US"/>
               <a:t>Fifth level</a:t>
             </a:r>
             <a:endParaRPr kumimoji="0" lang="en-US"/>
@@ -2637,7 +2649,7 @@
             <a:fld id="{1D8BD707-D9CF-40AE-B4C6-C98DA3205C09}" type="datetimeFigureOut">
               <a:rPr lang="en-US" smtClean="0"/>
               <a:pPr/>
-              <a:t>12/14/2023</a:t>
+              <a:t>12/18/2025</a:t>
             </a:fld>
             <a:endParaRPr lang="en-US"/>
           </a:p>
@@ -2849,10 +2861,9 @@
           <a:lstStyle/>
           <a:p>
             <a:r>
-              <a:rPr kumimoji="0" lang="en-US" smtClean="0"/>
+              <a:rPr kumimoji="0" lang="en-US"/>
               <a:t>Click to edit Master title style</a:t>
             </a:r>
-            <a:endParaRPr kumimoji="0" lang="en-US"/>
           </a:p>
         </p:txBody>
       </p:sp>
@@ -2874,7 +2885,7 @@
             <a:fld id="{1D8BD707-D9CF-40AE-B4C6-C98DA3205C09}" type="datetimeFigureOut">
               <a:rPr lang="en-US" smtClean="0"/>
               <a:pPr/>
-              <a:t>12/14/2023</a:t>
+              <a:t>12/18/2025</a:t>
             </a:fld>
             <a:endParaRPr lang="en-US"/>
           </a:p>
@@ -2945,35 +2956,35 @@
           <a:p>
             <a:pPr lvl="0" eaLnBrk="1" latinLnBrk="0" hangingPunct="1"/>
             <a:r>
-              <a:rPr lang="en-US" smtClean="0"/>
+              <a:rPr lang="en-US"/>
               <a:t>Click to edit Master text styles</a:t>
             </a:r>
           </a:p>
           <a:p>
             <a:pPr lvl="1" eaLnBrk="1" latinLnBrk="0" hangingPunct="1"/>
             <a:r>
-              <a:rPr lang="en-US" smtClean="0"/>
+              <a:rPr lang="en-US"/>
               <a:t>Second level</a:t>
             </a:r>
           </a:p>
           <a:p>
             <a:pPr lvl="2" eaLnBrk="1" latinLnBrk="0" hangingPunct="1"/>
             <a:r>
-              <a:rPr lang="en-US" smtClean="0"/>
+              <a:rPr lang="en-US"/>
               <a:t>Third level</a:t>
             </a:r>
           </a:p>
           <a:p>
             <a:pPr lvl="3" eaLnBrk="1" latinLnBrk="0" hangingPunct="1"/>
             <a:r>
-              <a:rPr lang="en-US" smtClean="0"/>
+              <a:rPr lang="en-US"/>
               <a:t>Fourth level</a:t>
             </a:r>
           </a:p>
           <a:p>
             <a:pPr lvl="4" eaLnBrk="1" latinLnBrk="0" hangingPunct="1"/>
             <a:r>
-              <a:rPr lang="en-US" smtClean="0"/>
+              <a:rPr lang="en-US"/>
               <a:t>Fifth level</a:t>
             </a:r>
             <a:endParaRPr kumimoji="0" lang="en-US"/>
@@ -3031,10 +3042,9 @@
           </a:lstStyle>
           <a:p>
             <a:r>
-              <a:rPr kumimoji="0" lang="en-US" smtClean="0"/>
+              <a:rPr kumimoji="0" lang="en-US"/>
               <a:t>Click to edit Master title style</a:t>
             </a:r>
-            <a:endParaRPr kumimoji="0" lang="en-US"/>
           </a:p>
         </p:txBody>
       </p:sp>
@@ -3111,7 +3121,7 @@
           <a:p>
             <a:pPr lvl="0" eaLnBrk="1" latinLnBrk="0" hangingPunct="1"/>
             <a:r>
-              <a:rPr kumimoji="0" lang="en-US" smtClean="0"/>
+              <a:rPr kumimoji="0" lang="en-US"/>
               <a:t>Click to edit Master text styles</a:t>
             </a:r>
           </a:p>
@@ -3140,7 +3150,7 @@
             <a:fld id="{1D8BD707-D9CF-40AE-B4C6-C98DA3205C09}" type="datetimeFigureOut">
               <a:rPr lang="en-US" smtClean="0"/>
               <a:pPr/>
-              <a:t>12/14/2023</a:t>
+              <a:t>12/18/2025</a:t>
             </a:fld>
             <a:endParaRPr lang="en-US"/>
           </a:p>
@@ -3337,10 +3347,9 @@
           <a:lstStyle/>
           <a:p>
             <a:r>
-              <a:rPr kumimoji="0" lang="en-US" smtClean="0"/>
+              <a:rPr kumimoji="0" lang="en-US"/>
               <a:t>Click to edit Master title style</a:t>
             </a:r>
-            <a:endParaRPr kumimoji="0" lang="en-US"/>
           </a:p>
         </p:txBody>
       </p:sp>
@@ -3362,7 +3371,7 @@
             <a:fld id="{1D8BD707-D9CF-40AE-B4C6-C98DA3205C09}" type="datetimeFigureOut">
               <a:rPr lang="en-US" smtClean="0"/>
               <a:pPr/>
-              <a:t>12/14/2023</a:t>
+              <a:t>12/18/2025</a:t>
             </a:fld>
             <a:endParaRPr lang="en-US"/>
           </a:p>
@@ -3433,35 +3442,35 @@
           <a:p>
             <a:pPr lvl="0" eaLnBrk="1" latinLnBrk="0" hangingPunct="1"/>
             <a:r>
-              <a:rPr lang="en-US" smtClean="0"/>
+              <a:rPr lang="en-US"/>
               <a:t>Click to edit Master text styles</a:t>
             </a:r>
           </a:p>
           <a:p>
             <a:pPr lvl="1" eaLnBrk="1" latinLnBrk="0" hangingPunct="1"/>
             <a:r>
-              <a:rPr lang="en-US" smtClean="0"/>
+              <a:rPr lang="en-US"/>
               <a:t>Second level</a:t>
             </a:r>
           </a:p>
           <a:p>
             <a:pPr lvl="2" eaLnBrk="1" latinLnBrk="0" hangingPunct="1"/>
             <a:r>
-              <a:rPr lang="en-US" smtClean="0"/>
+              <a:rPr lang="en-US"/>
               <a:t>Third level</a:t>
             </a:r>
           </a:p>
           <a:p>
             <a:pPr lvl="3" eaLnBrk="1" latinLnBrk="0" hangingPunct="1"/>
             <a:r>
-              <a:rPr lang="en-US" smtClean="0"/>
+              <a:rPr lang="en-US"/>
               <a:t>Fourth level</a:t>
             </a:r>
           </a:p>
           <a:p>
             <a:pPr lvl="4" eaLnBrk="1" latinLnBrk="0" hangingPunct="1"/>
             <a:r>
-              <a:rPr lang="en-US" smtClean="0"/>
+              <a:rPr lang="en-US"/>
               <a:t>Fifth level</a:t>
             </a:r>
             <a:endParaRPr kumimoji="0" lang="en-US"/>
@@ -3490,35 +3499,35 @@
           <a:p>
             <a:pPr lvl="0" eaLnBrk="1" latinLnBrk="0" hangingPunct="1"/>
             <a:r>
-              <a:rPr lang="en-US" smtClean="0"/>
+              <a:rPr lang="en-US"/>
               <a:t>Click to edit Master text styles</a:t>
             </a:r>
           </a:p>
           <a:p>
             <a:pPr lvl="1" eaLnBrk="1" latinLnBrk="0" hangingPunct="1"/>
             <a:r>
-              <a:rPr lang="en-US" smtClean="0"/>
+              <a:rPr lang="en-US"/>
               <a:t>Second level</a:t>
             </a:r>
           </a:p>
           <a:p>
             <a:pPr lvl="2" eaLnBrk="1" latinLnBrk="0" hangingPunct="1"/>
             <a:r>
-              <a:rPr lang="en-US" smtClean="0"/>
+              <a:rPr lang="en-US"/>
               <a:t>Third level</a:t>
             </a:r>
           </a:p>
           <a:p>
             <a:pPr lvl="3" eaLnBrk="1" latinLnBrk="0" hangingPunct="1"/>
             <a:r>
-              <a:rPr lang="en-US" smtClean="0"/>
+              <a:rPr lang="en-US"/>
               <a:t>Fourth level</a:t>
             </a:r>
           </a:p>
           <a:p>
             <a:pPr lvl="4" eaLnBrk="1" latinLnBrk="0" hangingPunct="1"/>
             <a:r>
-              <a:rPr lang="en-US" smtClean="0"/>
+              <a:rPr lang="en-US"/>
               <a:t>Fifth level</a:t>
             </a:r>
             <a:endParaRPr kumimoji="0" lang="en-US"/>
@@ -3575,10 +3584,9 @@
           </a:lstStyle>
           <a:p>
             <a:r>
-              <a:rPr kumimoji="0" lang="en-US" smtClean="0"/>
+              <a:rPr kumimoji="0" lang="en-US"/>
               <a:t>Click to edit Master title style</a:t>
             </a:r>
-            <a:endParaRPr kumimoji="0" lang="en-US"/>
           </a:p>
         </p:txBody>
       </p:sp>
@@ -3635,7 +3643,7 @@
           <a:p>
             <a:pPr lvl="0" eaLnBrk="1" latinLnBrk="0" hangingPunct="1"/>
             <a:r>
-              <a:rPr kumimoji="0" lang="en-US" smtClean="0"/>
+              <a:rPr kumimoji="0" lang="en-US"/>
               <a:t>Click to edit Master text styles</a:t>
             </a:r>
           </a:p>
@@ -3692,7 +3700,7 @@
           <a:p>
             <a:pPr lvl="0" eaLnBrk="1" latinLnBrk="0" hangingPunct="1"/>
             <a:r>
-              <a:rPr kumimoji="0" lang="en-US" smtClean="0"/>
+              <a:rPr kumimoji="0" lang="en-US"/>
               <a:t>Click to edit Master text styles</a:t>
             </a:r>
           </a:p>
@@ -3716,7 +3724,7 @@
             <a:fld id="{1D8BD707-D9CF-40AE-B4C6-C98DA3205C09}" type="datetimeFigureOut">
               <a:rPr lang="en-US" smtClean="0"/>
               <a:pPr/>
-              <a:t>12/14/2023</a:t>
+              <a:t>12/18/2025</a:t>
             </a:fld>
             <a:endParaRPr lang="en-US"/>
           </a:p>
@@ -3787,35 +3795,35 @@
           <a:p>
             <a:pPr lvl="0" eaLnBrk="1" latinLnBrk="0" hangingPunct="1"/>
             <a:r>
-              <a:rPr lang="en-US" smtClean="0"/>
+              <a:rPr lang="en-US"/>
               <a:t>Click to edit Master text styles</a:t>
             </a:r>
           </a:p>
           <a:p>
             <a:pPr lvl="1" eaLnBrk="1" latinLnBrk="0" hangingPunct="1"/>
             <a:r>
-              <a:rPr lang="en-US" smtClean="0"/>
+              <a:rPr lang="en-US"/>
               <a:t>Second level</a:t>
             </a:r>
           </a:p>
           <a:p>
             <a:pPr lvl="2" eaLnBrk="1" latinLnBrk="0" hangingPunct="1"/>
             <a:r>
-              <a:rPr lang="en-US" smtClean="0"/>
+              <a:rPr lang="en-US"/>
               <a:t>Third level</a:t>
             </a:r>
           </a:p>
           <a:p>
             <a:pPr lvl="3" eaLnBrk="1" latinLnBrk="0" hangingPunct="1"/>
             <a:r>
-              <a:rPr lang="en-US" smtClean="0"/>
+              <a:rPr lang="en-US"/>
               <a:t>Fourth level</a:t>
             </a:r>
           </a:p>
           <a:p>
             <a:pPr lvl="4" eaLnBrk="1" latinLnBrk="0" hangingPunct="1"/>
             <a:r>
-              <a:rPr lang="en-US" smtClean="0"/>
+              <a:rPr lang="en-US"/>
               <a:t>Fifth level</a:t>
             </a:r>
             <a:endParaRPr kumimoji="0" lang="en-US"/>
@@ -3844,35 +3852,35 @@
           <a:p>
             <a:pPr lvl="0" eaLnBrk="1" latinLnBrk="0" hangingPunct="1"/>
             <a:r>
-              <a:rPr lang="en-US" smtClean="0"/>
+              <a:rPr lang="en-US"/>
               <a:t>Click to edit Master text styles</a:t>
             </a:r>
           </a:p>
           <a:p>
             <a:pPr lvl="1" eaLnBrk="1" latinLnBrk="0" hangingPunct="1"/>
             <a:r>
-              <a:rPr lang="en-US" smtClean="0"/>
+              <a:rPr lang="en-US"/>
               <a:t>Second level</a:t>
             </a:r>
           </a:p>
           <a:p>
             <a:pPr lvl="2" eaLnBrk="1" latinLnBrk="0" hangingPunct="1"/>
             <a:r>
-              <a:rPr lang="en-US" smtClean="0"/>
+              <a:rPr lang="en-US"/>
               <a:t>Third level</a:t>
             </a:r>
           </a:p>
           <a:p>
             <a:pPr lvl="3" eaLnBrk="1" latinLnBrk="0" hangingPunct="1"/>
             <a:r>
-              <a:rPr lang="en-US" smtClean="0"/>
+              <a:rPr lang="en-US"/>
               <a:t>Fourth level</a:t>
             </a:r>
           </a:p>
           <a:p>
             <a:pPr lvl="4" eaLnBrk="1" latinLnBrk="0" hangingPunct="1"/>
             <a:r>
-              <a:rPr lang="en-US" smtClean="0"/>
+              <a:rPr lang="en-US"/>
               <a:t>Fifth level</a:t>
             </a:r>
             <a:endParaRPr kumimoji="0" lang="en-US"/>
@@ -3925,10 +3933,9 @@
           <a:lstStyle/>
           <a:p>
             <a:r>
-              <a:rPr kumimoji="0" lang="en-US" smtClean="0"/>
+              <a:rPr kumimoji="0" lang="en-US"/>
               <a:t>Click to edit Master title style</a:t>
             </a:r>
-            <a:endParaRPr kumimoji="0" lang="en-US"/>
           </a:p>
         </p:txBody>
       </p:sp>
@@ -3950,7 +3957,7 @@
             <a:fld id="{1D8BD707-D9CF-40AE-B4C6-C98DA3205C09}" type="datetimeFigureOut">
               <a:rPr lang="en-US" smtClean="0"/>
               <a:pPr/>
-              <a:t>12/14/2023</a:t>
+              <a:t>12/18/2025</a:t>
             </a:fld>
             <a:endParaRPr lang="en-US"/>
           </a:p>
@@ -4092,7 +4099,7 @@
             <a:fld id="{1D8BD707-D9CF-40AE-B4C6-C98DA3205C09}" type="datetimeFigureOut">
               <a:rPr lang="en-US" smtClean="0"/>
               <a:pPr/>
-              <a:t>12/14/2023</a:t>
+              <a:t>12/18/2025</a:t>
             </a:fld>
             <a:endParaRPr lang="en-US"/>
           </a:p>
@@ -4287,10 +4294,9 @@
           </a:lstStyle>
           <a:p>
             <a:r>
-              <a:rPr kumimoji="0" lang="en-US" smtClean="0"/>
+              <a:rPr kumimoji="0" lang="en-US"/>
               <a:t>Click to edit Master title style</a:t>
             </a:r>
-            <a:endParaRPr kumimoji="0" lang="en-US"/>
           </a:p>
         </p:txBody>
       </p:sp>
@@ -4347,7 +4353,7 @@
           <a:p>
             <a:pPr lvl="0" eaLnBrk="1" latinLnBrk="0" hangingPunct="1"/>
             <a:r>
-              <a:rPr kumimoji="0" lang="en-US" smtClean="0"/>
+              <a:rPr kumimoji="0" lang="en-US"/>
               <a:t>Click to edit Master text styles</a:t>
             </a:r>
           </a:p>
@@ -4371,7 +4377,7 @@
             <a:fld id="{1D8BD707-D9CF-40AE-B4C6-C98DA3205C09}" type="datetimeFigureOut">
               <a:rPr lang="en-US" smtClean="0"/>
               <a:pPr/>
-              <a:t>12/14/2023</a:t>
+              <a:t>12/18/2025</a:t>
             </a:fld>
             <a:endParaRPr lang="en-US"/>
           </a:p>
@@ -4564,35 +4570,35 @@
           <a:p>
             <a:pPr lvl="0" eaLnBrk="1" latinLnBrk="0" hangingPunct="1"/>
             <a:r>
-              <a:rPr lang="en-US" smtClean="0"/>
+              <a:rPr lang="en-US"/>
               <a:t>Click to edit Master text styles</a:t>
             </a:r>
           </a:p>
           <a:p>
             <a:pPr lvl="1" eaLnBrk="1" latinLnBrk="0" hangingPunct="1"/>
             <a:r>
-              <a:rPr lang="en-US" smtClean="0"/>
+              <a:rPr lang="en-US"/>
               <a:t>Second level</a:t>
             </a:r>
           </a:p>
           <a:p>
             <a:pPr lvl="2" eaLnBrk="1" latinLnBrk="0" hangingPunct="1"/>
             <a:r>
-              <a:rPr lang="en-US" smtClean="0"/>
+              <a:rPr lang="en-US"/>
               <a:t>Third level</a:t>
             </a:r>
           </a:p>
           <a:p>
             <a:pPr lvl="3" eaLnBrk="1" latinLnBrk="0" hangingPunct="1"/>
             <a:r>
-              <a:rPr lang="en-US" smtClean="0"/>
+              <a:rPr lang="en-US"/>
               <a:t>Fourth level</a:t>
             </a:r>
           </a:p>
           <a:p>
             <a:pPr lvl="4" eaLnBrk="1" latinLnBrk="0" hangingPunct="1"/>
             <a:r>
-              <a:rPr lang="en-US" smtClean="0"/>
+              <a:rPr lang="en-US"/>
               <a:t>Fifth level</a:t>
             </a:r>
             <a:endParaRPr kumimoji="0" lang="en-US"/>
@@ -4659,10 +4665,9 @@
           </a:lstStyle>
           <a:p>
             <a:r>
-              <a:rPr kumimoji="0" lang="en-US" smtClean="0"/>
+              <a:rPr kumimoji="0" lang="en-US"/>
               <a:t>Click to edit Master title style</a:t>
             </a:r>
-            <a:endParaRPr kumimoji="0" lang="en-US"/>
           </a:p>
         </p:txBody>
       </p:sp>
@@ -4704,7 +4709,7 @@
           </a:lstStyle>
           <a:p>
             <a:r>
-              <a:rPr kumimoji="0" lang="en-US" smtClean="0"/>
+              <a:rPr kumimoji="0" lang="en-US"/>
               <a:t>Click icon to add picture</a:t>
             </a:r>
             <a:endParaRPr kumimoji="0" lang="en-US" dirty="0"/>
@@ -4751,7 +4756,7 @@
           <a:p>
             <a:pPr lvl="0" eaLnBrk="1" latinLnBrk="0" hangingPunct="1"/>
             <a:r>
-              <a:rPr kumimoji="0" lang="en-US" smtClean="0"/>
+              <a:rPr kumimoji="0" lang="en-US"/>
               <a:t>Click to edit Master text styles</a:t>
             </a:r>
           </a:p>
@@ -4775,7 +4780,7 @@
             <a:fld id="{1D8BD707-D9CF-40AE-B4C6-C98DA3205C09}" type="datetimeFigureOut">
               <a:rPr lang="en-US" smtClean="0"/>
               <a:pPr/>
-              <a:t>12/14/2023</a:t>
+              <a:t>12/18/2025</a:t>
             </a:fld>
             <a:endParaRPr lang="en-US"/>
           </a:p>
@@ -5012,10 +5017,9 @@
           <a:lstStyle/>
           <a:p>
             <a:r>
-              <a:rPr kumimoji="0" lang="en-US" smtClean="0"/>
+              <a:rPr kumimoji="0" lang="en-US"/>
               <a:t>Click to edit Master title style</a:t>
             </a:r>
-            <a:endParaRPr kumimoji="0" lang="en-US"/>
           </a:p>
         </p:txBody>
       </p:sp>
@@ -5046,38 +5050,37 @@
           <a:p>
             <a:pPr lvl="0" eaLnBrk="1" latinLnBrk="0" hangingPunct="1"/>
             <a:r>
-              <a:rPr kumimoji="0" lang="en-US" smtClean="0"/>
+              <a:rPr kumimoji="0" lang="en-US"/>
               <a:t>Click to edit Master text styles</a:t>
             </a:r>
           </a:p>
           <a:p>
             <a:pPr lvl="1" eaLnBrk="1" latinLnBrk="0" hangingPunct="1"/>
             <a:r>
-              <a:rPr kumimoji="0" lang="en-US" smtClean="0"/>
+              <a:rPr kumimoji="0" lang="en-US"/>
               <a:t>Second level</a:t>
             </a:r>
           </a:p>
           <a:p>
             <a:pPr lvl="2" eaLnBrk="1" latinLnBrk="0" hangingPunct="1"/>
             <a:r>
-              <a:rPr kumimoji="0" lang="en-US" smtClean="0"/>
+              <a:rPr kumimoji="0" lang="en-US"/>
               <a:t>Third level</a:t>
             </a:r>
           </a:p>
           <a:p>
             <a:pPr lvl="3" eaLnBrk="1" latinLnBrk="0" hangingPunct="1"/>
             <a:r>
-              <a:rPr kumimoji="0" lang="en-US" smtClean="0"/>
+              <a:rPr kumimoji="0" lang="en-US"/>
               <a:t>Fourth level</a:t>
             </a:r>
           </a:p>
           <a:p>
             <a:pPr lvl="4" eaLnBrk="1" latinLnBrk="0" hangingPunct="1"/>
             <a:r>
-              <a:rPr kumimoji="0" lang="en-US" smtClean="0"/>
+              <a:rPr kumimoji="0" lang="en-US"/>
               <a:t>Fifth level</a:t>
             </a:r>
-            <a:endParaRPr kumimoji="0" lang="en-US"/>
           </a:p>
         </p:txBody>
       </p:sp>
@@ -5115,7 +5118,7 @@
             <a:fld id="{1D8BD707-D9CF-40AE-B4C6-C98DA3205C09}" type="datetimeFigureOut">
               <a:rPr lang="en-US" smtClean="0"/>
               <a:pPr/>
-              <a:t>12/14/2023</a:t>
+              <a:t>12/18/2025</a:t>
             </a:fld>
             <a:endParaRPr lang="en-US"/>
           </a:p>
@@ -5696,20 +5699,20 @@
           <a:lstStyle/>
           <a:p>
             <a:r>
-              <a:rPr lang="en-US" dirty="0" smtClean="0"/>
+              <a:rPr lang="en-US" dirty="0"/>
               <a:t>Data</a:t>
             </a:r>
             <a:br>
-              <a:rPr lang="en-US" dirty="0" smtClean="0"/>
+              <a:rPr lang="en-US" dirty="0"/>
             </a:br>
             <a:r>
-              <a:rPr lang="en-US" sz="1800" dirty="0" smtClean="0">
+              <a:rPr lang="en-US" sz="1800" dirty="0">
                 <a:hlinkClick r:id="rId3"/>
               </a:rPr>
               <a:t>www.cs.uoi.gr/~zarras/soft-devII.htm</a:t>
             </a:r>
             <a:r>
-              <a:rPr lang="en-US" sz="1800" dirty="0" smtClean="0"/>
+              <a:rPr lang="en-US" sz="1800" dirty="0"/>
               <a:t>    </a:t>
             </a:r>
             <a:endParaRPr lang="el-GR" sz="1800" dirty="0"/>
@@ -5734,21 +5737,21 @@
           <a:lstStyle/>
           <a:p>
             <a:r>
-              <a:rPr lang="en-US" dirty="0" smtClean="0"/>
+              <a:rPr lang="en-US" dirty="0"/>
               <a:t>Sources: M. Fowler </a:t>
             </a:r>
             <a:r>
-              <a:rPr lang="en-US" dirty="0" err="1" smtClean="0"/>
+              <a:rPr lang="en-US" dirty="0" err="1"/>
               <a:t>Refactorings</a:t>
             </a:r>
             <a:r>
-              <a:rPr lang="en-US" dirty="0" smtClean="0"/>
+              <a:rPr lang="en-US" dirty="0"/>
               <a:t> Catalog</a:t>
             </a:r>
           </a:p>
           <a:p>
             <a:r>
-              <a:rPr lang="en-US" dirty="0" smtClean="0"/>
+              <a:rPr lang="en-US" dirty="0"/>
               <a:t>W. Wake Refactoring Workbook</a:t>
             </a:r>
             <a:endParaRPr lang="el-GR" dirty="0"/>
@@ -5760,13 +5763,6 @@
   <p:clrMapOvr>
     <a:masterClrMapping/>
   </p:clrMapOvr>
-  <p:timing>
-    <p:tnLst>
-      <p:par>
-        <p:cTn id="1" dur="indefinite" restart="never" nodeType="tmRoot"/>
-      </p:par>
-    </p:tnLst>
-  </p:timing>
 </p:sld>
 </file>
 
@@ -5803,10 +5799,10 @@
           <a:lstStyle/>
           <a:p>
             <a:r>
-              <a:rPr lang="en-US" dirty="0" smtClean="0"/>
+              <a:rPr lang="en-US" dirty="0"/>
               <a:t>Primitive Obsession</a:t>
             </a:r>
-            <a:endParaRPr lang="el-GR" dirty="0" smtClean="0"/>
+            <a:endParaRPr lang="el-GR" dirty="0"/>
           </a:p>
         </p:txBody>
       </p:sp>
@@ -5832,7 +5828,7 @@
           <a:lstStyle/>
           <a:p>
             <a:r>
-              <a:rPr lang="en-US" b="1" u="sng" dirty="0" smtClean="0">
+              <a:rPr lang="en-US" b="1" u="sng" dirty="0">
                 <a:solidFill>
                   <a:srgbClr val="0070C0"/>
                 </a:solidFill>
@@ -5841,12 +5837,12 @@
             </a:r>
           </a:p>
           <a:p>
-            <a:endParaRPr lang="en-US" b="1" dirty="0" smtClean="0"/>
+            <a:endParaRPr lang="en-US" b="1" dirty="0"/>
           </a:p>
           <a:p>
             <a:pPr marL="342900" indent="-342900"/>
             <a:r>
-              <a:rPr lang="en-US" dirty="0" smtClean="0">
+              <a:rPr lang="en-US" dirty="0">
                 <a:solidFill>
                   <a:srgbClr val="0070C0"/>
                 </a:solidFill>
@@ -5854,22 +5850,22 @@
               <a:t>For simulated types</a:t>
             </a:r>
             <a:r>
-              <a:rPr lang="en-US" dirty="0" smtClean="0"/>
+              <a:rPr lang="en-US" dirty="0"/>
               <a:t>: an integer type code stands in for a class.</a:t>
             </a:r>
           </a:p>
           <a:p>
             <a:pPr marL="800100" lvl="1" indent="-342900"/>
-            <a:endParaRPr lang="en-US" dirty="0" smtClean="0"/>
+            <a:endParaRPr lang="en-US" dirty="0"/>
           </a:p>
           <a:p>
             <a:pPr marL="800100" lvl="1" indent="-342900"/>
             <a:r>
-              <a:rPr lang="en-US" dirty="0" smtClean="0"/>
+              <a:rPr lang="en-US" dirty="0"/>
               <a:t>If the </a:t>
             </a:r>
             <a:r>
-              <a:rPr lang="en-US" b="1" dirty="0" smtClean="0">
+              <a:rPr lang="en-US" b="1" dirty="0">
                 <a:solidFill>
                   <a:srgbClr val="0070C0"/>
                 </a:solidFill>
@@ -5877,7 +5873,7 @@
               <a:t>behavior of the object depends on the </a:t>
             </a:r>
             <a:r>
-              <a:rPr lang="en-US" b="1" dirty="0" err="1" smtClean="0">
+              <a:rPr lang="en-US" b="1" dirty="0" err="1">
                 <a:solidFill>
                   <a:srgbClr val="0070C0"/>
                 </a:solidFill>
@@ -5885,7 +5881,7 @@
               <a:t>typecode</a:t>
             </a:r>
             <a:r>
-              <a:rPr lang="en-US" b="1" dirty="0" smtClean="0">
+              <a:rPr lang="en-US" b="1" dirty="0">
                 <a:solidFill>
                   <a:srgbClr val="0070C0"/>
                 </a:solidFill>
@@ -5893,19 +5889,19 @@
               <a:t> </a:t>
             </a:r>
             <a:r>
-              <a:rPr lang="en-US" dirty="0" smtClean="0"/>
+              <a:rPr lang="en-US" dirty="0"/>
               <a:t>and the </a:t>
             </a:r>
             <a:r>
-              <a:rPr lang="en-US" dirty="0" err="1" smtClean="0"/>
+              <a:rPr lang="en-US" dirty="0" err="1"/>
               <a:t>typecode</a:t>
             </a:r>
             <a:r>
-              <a:rPr lang="en-US" dirty="0" smtClean="0"/>
+              <a:rPr lang="en-US" dirty="0"/>
               <a:t> value is </a:t>
             </a:r>
             <a:r>
-              <a:rPr lang="en-US" b="1" dirty="0" smtClean="0">
+              <a:rPr lang="en-US" b="1" dirty="0">
                 <a:solidFill>
                   <a:srgbClr val="0070C0"/>
                 </a:solidFill>
@@ -5913,19 +5909,19 @@
               <a:t>immutable during the lifetime of the object</a:t>
             </a:r>
             <a:r>
-              <a:rPr lang="en-US" dirty="0" smtClean="0"/>
+              <a:rPr lang="en-US" dirty="0"/>
               <a:t>, and the class is not </a:t>
             </a:r>
             <a:r>
-              <a:rPr lang="en-US" dirty="0" err="1" smtClean="0"/>
+              <a:rPr lang="en-US" dirty="0" err="1"/>
               <a:t>subclassed</a:t>
             </a:r>
             <a:r>
-              <a:rPr lang="en-US" dirty="0" smtClean="0"/>
+              <a:rPr lang="en-US" dirty="0"/>
               <a:t> already, </a:t>
             </a:r>
             <a:r>
-              <a:rPr lang="en-US" b="1" i="1" dirty="0" smtClean="0">
+              <a:rPr lang="en-US" b="1" i="1" dirty="0">
                 <a:solidFill>
                   <a:srgbClr val="0070C0"/>
                 </a:solidFill>
@@ -5933,12 +5929,12 @@
               <a:t>Replace Type Code with Subclass</a:t>
             </a:r>
             <a:r>
-              <a:rPr lang="en-US" i="1" dirty="0" smtClean="0"/>
+              <a:rPr lang="en-US" i="1" dirty="0"/>
               <a:t>.</a:t>
             </a:r>
           </a:p>
           <a:p>
-            <a:endParaRPr lang="en-US" i="1" dirty="0" smtClean="0"/>
+            <a:endParaRPr lang="en-US" i="1" dirty="0"/>
           </a:p>
         </p:txBody>
       </p:sp>
@@ -5947,13 +5943,6 @@
   <p:clrMapOvr>
     <a:masterClrMapping/>
   </p:clrMapOvr>
-  <p:timing>
-    <p:tnLst>
-      <p:par>
-        <p:cTn id="1" dur="indefinite" restart="never" nodeType="tmRoot"/>
-      </p:par>
-    </p:tnLst>
-  </p:timing>
 </p:sld>
 </file>
 
@@ -5990,10 +5979,10 @@
           <a:lstStyle/>
           <a:p>
             <a:r>
-              <a:rPr lang="en-US" dirty="0" smtClean="0"/>
+              <a:rPr lang="en-US" dirty="0"/>
               <a:t>Replace Type Code with Subclass</a:t>
             </a:r>
-            <a:endParaRPr lang="el-GR" dirty="0" smtClean="0"/>
+            <a:endParaRPr lang="el-GR" dirty="0"/>
           </a:p>
         </p:txBody>
       </p:sp>
@@ -6114,13 +6103,6 @@
   <p:clrMapOvr>
     <a:masterClrMapping/>
   </p:clrMapOvr>
-  <p:timing>
-    <p:tnLst>
-      <p:par>
-        <p:cTn id="1" dur="indefinite" restart="never" nodeType="tmRoot"/>
-      </p:par>
-    </p:tnLst>
-  </p:timing>
 </p:sld>
 </file>
 
@@ -6157,10 +6139,10 @@
           <a:lstStyle/>
           <a:p>
             <a:r>
-              <a:rPr lang="en-US" dirty="0" smtClean="0"/>
+              <a:rPr lang="en-US" dirty="0"/>
               <a:t>Replace Type Code with Subclass</a:t>
             </a:r>
-            <a:endParaRPr lang="el-GR" dirty="0" smtClean="0"/>
+            <a:endParaRPr lang="el-GR" dirty="0"/>
           </a:p>
         </p:txBody>
       </p:sp>
@@ -6281,13 +6263,6 @@
   <p:clrMapOvr>
     <a:masterClrMapping/>
   </p:clrMapOvr>
-  <p:timing>
-    <p:tnLst>
-      <p:par>
-        <p:cTn id="1" dur="indefinite" restart="never" nodeType="tmRoot"/>
-      </p:par>
-    </p:tnLst>
-  </p:timing>
 </p:sld>
 </file>
 
@@ -6324,10 +6299,10 @@
           <a:lstStyle/>
           <a:p>
             <a:r>
-              <a:rPr lang="en-US" dirty="0" smtClean="0"/>
+              <a:rPr lang="en-US" dirty="0"/>
               <a:t>Primitive Obsession</a:t>
             </a:r>
-            <a:endParaRPr lang="el-GR" dirty="0" smtClean="0"/>
+            <a:endParaRPr lang="el-GR" dirty="0"/>
           </a:p>
         </p:txBody>
       </p:sp>
@@ -6353,7 +6328,7 @@
           <a:lstStyle/>
           <a:p>
             <a:r>
-              <a:rPr lang="en-US" b="1" u="sng" dirty="0" smtClean="0">
+              <a:rPr lang="en-US" b="1" u="sng" dirty="0">
                 <a:solidFill>
                   <a:srgbClr val="0070C0"/>
                 </a:solidFill>
@@ -6362,12 +6337,12 @@
             </a:r>
           </a:p>
           <a:p>
-            <a:endParaRPr lang="en-US" b="1" dirty="0" smtClean="0"/>
+            <a:endParaRPr lang="en-US" b="1" dirty="0"/>
           </a:p>
           <a:p>
             <a:pPr marL="342900" indent="-342900"/>
             <a:r>
-              <a:rPr lang="en-US" dirty="0" smtClean="0">
+              <a:rPr lang="en-US" dirty="0">
                 <a:solidFill>
                   <a:srgbClr val="0070C0"/>
                 </a:solidFill>
@@ -6375,26 +6350,26 @@
               <a:t>For simulated types</a:t>
             </a:r>
             <a:r>
-              <a:rPr lang="en-US" dirty="0" smtClean="0"/>
+              <a:rPr lang="en-US" dirty="0"/>
               <a:t>: an integer type code stands in for a class.</a:t>
             </a:r>
           </a:p>
           <a:p>
             <a:pPr marL="800100" lvl="1" indent="-342900"/>
             <a:r>
-              <a:rPr lang="en-US" dirty="0" smtClean="0"/>
+              <a:rPr lang="en-US" dirty="0"/>
               <a:t>If the behavior of the object depends on the </a:t>
             </a:r>
             <a:r>
-              <a:rPr lang="en-US" dirty="0" err="1" smtClean="0"/>
+              <a:rPr lang="en-US" dirty="0" err="1"/>
               <a:t>typecode</a:t>
             </a:r>
             <a:r>
-              <a:rPr lang="en-US" dirty="0" smtClean="0"/>
+              <a:rPr lang="en-US" dirty="0"/>
               <a:t> and the </a:t>
             </a:r>
             <a:r>
-              <a:rPr lang="en-US" dirty="0" smtClean="0">
+              <a:rPr lang="en-US" dirty="0">
                 <a:solidFill>
                   <a:srgbClr val="0070C0"/>
                 </a:solidFill>
@@ -6402,7 +6377,7 @@
               <a:t>type code changes during the lifetime of the object (</a:t>
             </a:r>
             <a:r>
-              <a:rPr lang="en-US" dirty="0" smtClean="0">
+              <a:rPr lang="en-US" dirty="0">
                 <a:solidFill>
                   <a:srgbClr val="FF0000"/>
                 </a:solidFill>
@@ -6410,7 +6385,7 @@
               <a:t>or the class is </a:t>
             </a:r>
             <a:r>
-              <a:rPr lang="en-US" dirty="0" err="1" smtClean="0">
+              <a:rPr lang="en-US" dirty="0" err="1">
                 <a:solidFill>
                   <a:srgbClr val="FF0000"/>
                 </a:solidFill>
@@ -6418,7 +6393,7 @@
               <a:t>subclassed</a:t>
             </a:r>
             <a:r>
-              <a:rPr lang="en-US" dirty="0" smtClean="0">
+              <a:rPr lang="en-US" dirty="0">
                 <a:solidFill>
                   <a:srgbClr val="FF0000"/>
                 </a:solidFill>
@@ -6426,11 +6401,11 @@
               <a:t> already)</a:t>
             </a:r>
             <a:r>
-              <a:rPr lang="en-US" dirty="0" smtClean="0"/>
+              <a:rPr lang="en-US" dirty="0"/>
               <a:t>,  </a:t>
             </a:r>
             <a:r>
-              <a:rPr lang="en-US" b="1" i="1" dirty="0" smtClean="0">
+              <a:rPr lang="en-US" b="1" i="1" dirty="0">
                 <a:solidFill>
                   <a:srgbClr val="0070C0"/>
                 </a:solidFill>
@@ -6438,12 +6413,12 @@
               <a:t>Replace Type Code with Strategy</a:t>
             </a:r>
             <a:r>
-              <a:rPr lang="en-US" i="1" dirty="0" smtClean="0"/>
+              <a:rPr lang="en-US" i="1" dirty="0"/>
               <a:t>. </a:t>
             </a:r>
           </a:p>
           <a:p>
-            <a:endParaRPr lang="en-US" i="1" dirty="0" smtClean="0"/>
+            <a:endParaRPr lang="en-US" i="1" dirty="0"/>
           </a:p>
         </p:txBody>
       </p:sp>
@@ -6452,13 +6427,6 @@
   <p:clrMapOvr>
     <a:masterClrMapping/>
   </p:clrMapOvr>
-  <p:timing>
-    <p:tnLst>
-      <p:par>
-        <p:cTn id="1" dur="indefinite" restart="never" nodeType="tmRoot"/>
-      </p:par>
-    </p:tnLst>
-  </p:timing>
 </p:sld>
 </file>
 
@@ -6495,10 +6463,9 @@
           <a:lstStyle/>
           <a:p>
             <a:r>
-              <a:rPr lang="en-US" dirty="0" smtClean="0"/>
+              <a:rPr lang="en-US" dirty="0"/>
               <a:t>Replace Type Code with Strategy</a:t>
             </a:r>
-            <a:endParaRPr lang="en-US" dirty="0"/>
           </a:p>
         </p:txBody>
       </p:sp>
@@ -6561,11 +6528,11 @@
               <a:buNone/>
             </a:pPr>
             <a:r>
-              <a:rPr lang="en-US" dirty="0" smtClean="0"/>
+              <a:rPr lang="en-US" dirty="0"/>
               <a:t>Apply the </a:t>
             </a:r>
             <a:r>
-              <a:rPr lang="en-US" dirty="0" smtClean="0">
+              <a:rPr lang="en-US" dirty="0">
                 <a:solidFill>
                   <a:srgbClr val="C00000"/>
                 </a:solidFill>
@@ -6573,11 +6540,11 @@
               <a:t>Strategy pattern</a:t>
             </a:r>
             <a:r>
-              <a:rPr lang="en-US" dirty="0" smtClean="0"/>
+              <a:rPr lang="en-US" dirty="0"/>
               <a:t>, i.e., encapsulate the </a:t>
             </a:r>
             <a:r>
-              <a:rPr lang="en-US" dirty="0" err="1" smtClean="0">
+              <a:rPr lang="en-US" dirty="0" err="1">
                 <a:solidFill>
                   <a:srgbClr val="C00000"/>
                 </a:solidFill>
@@ -6585,7 +6552,7 @@
               <a:t>typecode</a:t>
             </a:r>
             <a:r>
-              <a:rPr lang="en-US" dirty="0" smtClean="0">
+              <a:rPr lang="en-US" dirty="0">
                 <a:solidFill>
                   <a:srgbClr val="C00000"/>
                 </a:solidFill>
@@ -6593,11 +6560,11 @@
               <a:t> dependent behavior</a:t>
             </a:r>
             <a:r>
-              <a:rPr lang="en-US" dirty="0" smtClean="0"/>
+              <a:rPr lang="en-US" dirty="0"/>
               <a:t> into </a:t>
             </a:r>
             <a:r>
-              <a:rPr lang="en-US" dirty="0" smtClean="0">
+              <a:rPr lang="en-US" dirty="0">
                 <a:solidFill>
                   <a:srgbClr val="C00000"/>
                 </a:solidFill>
@@ -6605,7 +6572,7 @@
               <a:t>separate objects </a:t>
             </a:r>
             <a:r>
-              <a:rPr lang="en-US" dirty="0" smtClean="0"/>
+              <a:rPr lang="en-US" dirty="0"/>
               <a:t>with polymorphic interfaces and delegate calls to these objects</a:t>
             </a:r>
           </a:p>
@@ -6690,10 +6657,9 @@
           <a:lstStyle/>
           <a:p>
             <a:r>
-              <a:rPr lang="en-US" dirty="0" smtClean="0"/>
+              <a:rPr lang="en-US" dirty="0"/>
               <a:t>Replace Type Code with Strategy</a:t>
             </a:r>
-            <a:endParaRPr lang="en-US" dirty="0"/>
           </a:p>
         </p:txBody>
       </p:sp>
@@ -6723,11 +6689,11 @@
               <a:buNone/>
             </a:pPr>
             <a:r>
-              <a:rPr lang="en-US" dirty="0" smtClean="0"/>
+              <a:rPr lang="en-US" dirty="0"/>
               <a:t>Apply the </a:t>
             </a:r>
             <a:r>
-              <a:rPr lang="en-US" dirty="0" smtClean="0">
+              <a:rPr lang="en-US" dirty="0">
                 <a:solidFill>
                   <a:srgbClr val="C00000"/>
                 </a:solidFill>
@@ -6735,11 +6701,11 @@
               <a:t>Strategy pattern</a:t>
             </a:r>
             <a:r>
-              <a:rPr lang="en-US" dirty="0" smtClean="0"/>
+              <a:rPr lang="en-US" dirty="0"/>
               <a:t>, i.e., encapsulate the </a:t>
             </a:r>
             <a:r>
-              <a:rPr lang="en-US" dirty="0" err="1" smtClean="0">
+              <a:rPr lang="en-US" dirty="0" err="1">
                 <a:solidFill>
                   <a:srgbClr val="C00000"/>
                 </a:solidFill>
@@ -6747,7 +6713,7 @@
               <a:t>typecode</a:t>
             </a:r>
             <a:r>
-              <a:rPr lang="en-US" dirty="0" smtClean="0">
+              <a:rPr lang="en-US" dirty="0">
                 <a:solidFill>
                   <a:srgbClr val="C00000"/>
                 </a:solidFill>
@@ -6755,11 +6721,11 @@
               <a:t> dependent behavior</a:t>
             </a:r>
             <a:r>
-              <a:rPr lang="en-US" dirty="0" smtClean="0"/>
+              <a:rPr lang="en-US" dirty="0"/>
               <a:t> into </a:t>
             </a:r>
             <a:r>
-              <a:rPr lang="en-US" dirty="0" smtClean="0">
+              <a:rPr lang="en-US" dirty="0">
                 <a:solidFill>
                   <a:srgbClr val="C00000"/>
                 </a:solidFill>
@@ -6767,7 +6733,7 @@
               <a:t>separate objects </a:t>
             </a:r>
             <a:r>
-              <a:rPr lang="en-US" dirty="0" smtClean="0"/>
+              <a:rPr lang="en-US" dirty="0"/>
               <a:t>with polymorphic interfaces and delegate calls to these objects</a:t>
             </a:r>
           </a:p>
@@ -6814,10 +6780,9 @@
           <a:lstStyle/>
           <a:p>
             <a:r>
-              <a:rPr lang="en-US" dirty="0" smtClean="0"/>
+              <a:rPr lang="en-US" dirty="0"/>
               <a:t>Data Class/Container</a:t>
             </a:r>
-            <a:endParaRPr lang="en-US" dirty="0"/>
           </a:p>
         </p:txBody>
       </p:sp>
@@ -6881,10 +6846,10 @@
           <a:lstStyle/>
           <a:p>
             <a:r>
-              <a:rPr lang="en-US" dirty="0" smtClean="0"/>
+              <a:rPr lang="en-US" dirty="0"/>
               <a:t>Data Class/Container</a:t>
             </a:r>
-            <a:endParaRPr lang="el-GR" dirty="0" smtClean="0"/>
+            <a:endParaRPr lang="el-GR" dirty="0"/>
           </a:p>
         </p:txBody>
       </p:sp>
@@ -6910,7 +6875,7 @@
           <a:lstStyle/>
           <a:p>
             <a:r>
-              <a:rPr lang="en-US" b="1" u="sng" dirty="0" smtClean="0">
+              <a:rPr lang="en-US" b="1" u="sng" dirty="0">
                 <a:solidFill>
                   <a:srgbClr val="0070C0"/>
                 </a:solidFill>
@@ -6919,15 +6884,15 @@
             </a:r>
           </a:p>
           <a:p>
-            <a:endParaRPr lang="en-US" dirty="0" smtClean="0"/>
-          </a:p>
-          <a:p>
-            <a:r>
-              <a:rPr lang="en-US" dirty="0" smtClean="0"/>
+            <a:endParaRPr lang="en-US" dirty="0"/>
+          </a:p>
+          <a:p>
+            <a:r>
+              <a:rPr lang="en-US" dirty="0"/>
               <a:t>The class consists only of </a:t>
             </a:r>
             <a:r>
-              <a:rPr lang="en-US" dirty="0" smtClean="0">
+              <a:rPr lang="en-US" dirty="0">
                 <a:solidFill>
                   <a:srgbClr val="FF0000"/>
                 </a:solidFill>
@@ -6935,11 +6900,11 @@
               <a:t>public data members</a:t>
             </a:r>
             <a:r>
-              <a:rPr lang="en-US" dirty="0" smtClean="0"/>
+              <a:rPr lang="en-US" dirty="0"/>
               <a:t>, or of </a:t>
             </a:r>
             <a:r>
-              <a:rPr lang="en-US" dirty="0" smtClean="0">
+              <a:rPr lang="en-US" dirty="0">
                 <a:solidFill>
                   <a:srgbClr val="FF0000"/>
                 </a:solidFill>
@@ -6947,16 +6912,16 @@
               <a:t>simple getting and setting methods</a:t>
             </a:r>
             <a:r>
-              <a:rPr lang="en-US" dirty="0" smtClean="0"/>
+              <a:rPr lang="en-US" dirty="0"/>
               <a:t>.</a:t>
             </a:r>
           </a:p>
           <a:p>
-            <a:endParaRPr lang="en-US" b="1" dirty="0" smtClean="0"/>
-          </a:p>
-          <a:p>
-            <a:r>
-              <a:rPr lang="en-US" b="1" u="sng" dirty="0" smtClean="0">
+            <a:endParaRPr lang="en-US" b="1" dirty="0"/>
+          </a:p>
+          <a:p>
+            <a:r>
+              <a:rPr lang="en-US" b="1" u="sng" dirty="0">
                 <a:solidFill>
                   <a:srgbClr val="0070C0"/>
                 </a:solidFill>
@@ -6965,16 +6930,16 @@
             </a:r>
           </a:p>
           <a:p>
-            <a:endParaRPr lang="en-US" dirty="0" smtClean="0"/>
+            <a:endParaRPr lang="en-US" dirty="0"/>
           </a:p>
           <a:p>
             <a:pPr algn="just"/>
             <a:r>
-              <a:rPr lang="en-US" dirty="0" smtClean="0"/>
+              <a:rPr lang="en-US" dirty="0"/>
               <a:t>It’s </a:t>
             </a:r>
             <a:r>
-              <a:rPr lang="en-US" dirty="0" smtClean="0">
+              <a:rPr lang="en-US" dirty="0">
                 <a:solidFill>
                   <a:srgbClr val="0070C0"/>
                 </a:solidFill>
@@ -6982,11 +6947,11 @@
               <a:t>common for classes to begin like this</a:t>
             </a:r>
             <a:r>
-              <a:rPr lang="en-US" dirty="0" smtClean="0"/>
+              <a:rPr lang="en-US" dirty="0"/>
               <a:t>: you realize that some data is part of an independent object, so you extract it out. But objects are about the commonality of </a:t>
             </a:r>
             <a:r>
-              <a:rPr lang="en-US" i="1" dirty="0" smtClean="0"/>
+              <a:rPr lang="en-US" i="1" dirty="0"/>
               <a:t>behavior, and these objects aren’t developed enough to have much behavior yet.</a:t>
             </a:r>
           </a:p>
@@ -6997,13 +6962,6 @@
   <p:clrMapOvr>
     <a:masterClrMapping/>
   </p:clrMapOvr>
-  <p:timing>
-    <p:tnLst>
-      <p:par>
-        <p:cTn id="1" dur="indefinite" restart="never" nodeType="tmRoot"/>
-      </p:par>
-    </p:tnLst>
-  </p:timing>
 </p:sld>
 </file>
 
@@ -7040,10 +6998,10 @@
           <a:lstStyle/>
           <a:p>
             <a:r>
-              <a:rPr lang="en-US" dirty="0" smtClean="0"/>
+              <a:rPr lang="en-US" dirty="0"/>
               <a:t>Data Class/Container</a:t>
             </a:r>
-            <a:endParaRPr lang="el-GR" dirty="0" smtClean="0"/>
+            <a:endParaRPr lang="el-GR" dirty="0"/>
           </a:p>
         </p:txBody>
       </p:sp>
@@ -7069,7 +7027,7 @@
           <a:lstStyle/>
           <a:p>
             <a:r>
-              <a:rPr lang="en-US" b="1" u="sng" dirty="0" smtClean="0">
+              <a:rPr lang="en-US" b="1" u="sng" dirty="0">
                 <a:solidFill>
                   <a:srgbClr val="0070C0"/>
                 </a:solidFill>
@@ -7078,12 +7036,12 @@
             </a:r>
           </a:p>
           <a:p>
-            <a:endParaRPr lang="en-US" b="1" i="1" dirty="0" smtClean="0"/>
+            <a:endParaRPr lang="en-US" b="1" i="1" dirty="0"/>
           </a:p>
           <a:p>
             <a:pPr marL="342900" indent="-342900"/>
             <a:r>
-              <a:rPr lang="en-US" i="1" dirty="0" smtClean="0">
+              <a:rPr lang="en-US" i="1" dirty="0">
                 <a:solidFill>
                   <a:srgbClr val="0070C0"/>
                 </a:solidFill>
@@ -7091,17 +7049,17 @@
               <a:t>Encapsulate Field</a:t>
             </a:r>
             <a:r>
-              <a:rPr lang="en-US" i="1" dirty="0" smtClean="0"/>
+              <a:rPr lang="en-US" i="1" dirty="0"/>
               <a:t> to block direct access to the fields (allowing access only </a:t>
             </a:r>
             <a:r>
-              <a:rPr lang="en-US" dirty="0" smtClean="0"/>
+              <a:rPr lang="en-US" dirty="0"/>
               <a:t>through getters and setters).</a:t>
             </a:r>
           </a:p>
           <a:p>
             <a:pPr marL="342900" indent="-342900"/>
-            <a:endParaRPr lang="en-US" i="1" dirty="0" smtClean="0"/>
+            <a:endParaRPr lang="en-US" i="1" dirty="0"/>
           </a:p>
         </p:txBody>
       </p:sp>
@@ -7110,13 +7068,6 @@
   <p:clrMapOvr>
     <a:masterClrMapping/>
   </p:clrMapOvr>
-  <p:timing>
-    <p:tnLst>
-      <p:par>
-        <p:cTn id="1" dur="indefinite" restart="never" nodeType="tmRoot"/>
-      </p:par>
-    </p:tnLst>
-  </p:timing>
 </p:sld>
 </file>
 
@@ -7153,10 +7104,9 @@
           <a:lstStyle/>
           <a:p>
             <a:r>
-              <a:rPr lang="en-US" dirty="0" smtClean="0"/>
+              <a:rPr lang="en-US" dirty="0"/>
               <a:t>Encapsulate Field</a:t>
             </a:r>
-            <a:endParaRPr lang="en-US" dirty="0"/>
           </a:p>
         </p:txBody>
       </p:sp>
@@ -7234,10 +7184,9 @@
           <a:lstStyle/>
           <a:p>
             <a:r>
-              <a:rPr lang="en-US" dirty="0" smtClean="0"/>
+              <a:rPr lang="en-US" dirty="0"/>
               <a:t>Primitive Obsession</a:t>
             </a:r>
-            <a:endParaRPr lang="en-US" dirty="0"/>
           </a:p>
         </p:txBody>
       </p:sp>
@@ -7301,10 +7250,10 @@
           <a:lstStyle/>
           <a:p>
             <a:r>
-              <a:rPr lang="en-US" dirty="0" smtClean="0"/>
+              <a:rPr lang="en-US" dirty="0"/>
               <a:t>Data Class/Container</a:t>
             </a:r>
-            <a:endParaRPr lang="el-GR" dirty="0" smtClean="0"/>
+            <a:endParaRPr lang="el-GR" dirty="0"/>
           </a:p>
         </p:txBody>
       </p:sp>
@@ -7330,7 +7279,7 @@
           <a:lstStyle/>
           <a:p>
             <a:r>
-              <a:rPr lang="en-US" b="1" u="sng" dirty="0" smtClean="0">
+              <a:rPr lang="en-US" b="1" u="sng" dirty="0">
                 <a:solidFill>
                   <a:srgbClr val="0070C0"/>
                 </a:solidFill>
@@ -7339,12 +7288,12 @@
             </a:r>
           </a:p>
           <a:p>
-            <a:endParaRPr lang="en-US" b="1" i="1" dirty="0" smtClean="0"/>
+            <a:endParaRPr lang="en-US" b="1" i="1" dirty="0"/>
           </a:p>
           <a:p>
             <a:pPr marL="342900" indent="-342900"/>
             <a:r>
-              <a:rPr lang="en-US" i="1" dirty="0" smtClean="0">
+              <a:rPr lang="en-US" i="1" dirty="0">
                 <a:solidFill>
                   <a:srgbClr val="0070C0"/>
                 </a:solidFill>
@@ -7352,7 +7301,7 @@
               <a:t>Encapsulate Collection </a:t>
             </a:r>
             <a:r>
-              <a:rPr lang="en-US" i="1" dirty="0" smtClean="0"/>
+              <a:rPr lang="en-US" i="1" dirty="0"/>
               <a:t>to remove direct access to any collection-type fields.</a:t>
             </a:r>
           </a:p>
@@ -7363,13 +7312,6 @@
   <p:clrMapOvr>
     <a:masterClrMapping/>
   </p:clrMapOvr>
-  <p:timing>
-    <p:tnLst>
-      <p:par>
-        <p:cTn id="1" dur="indefinite" restart="never" nodeType="tmRoot"/>
-      </p:par>
-    </p:tnLst>
-  </p:timing>
 </p:sld>
 </file>
 
@@ -7406,10 +7348,9 @@
           <a:lstStyle/>
           <a:p>
             <a:r>
-              <a:rPr lang="en-US" dirty="0" smtClean="0"/>
+              <a:rPr lang="en-US" dirty="0"/>
               <a:t>Encapsulate Collection</a:t>
             </a:r>
-            <a:endParaRPr lang="en-US" dirty="0"/>
           </a:p>
         </p:txBody>
       </p:sp>
@@ -7487,10 +7428,10 @@
           <a:lstStyle/>
           <a:p>
             <a:r>
-              <a:rPr lang="en-US" dirty="0" smtClean="0"/>
+              <a:rPr lang="en-US" dirty="0"/>
               <a:t>Data Class/Container</a:t>
             </a:r>
-            <a:endParaRPr lang="el-GR" dirty="0" smtClean="0"/>
+            <a:endParaRPr lang="el-GR" dirty="0"/>
           </a:p>
         </p:txBody>
       </p:sp>
@@ -7516,7 +7457,7 @@
           <a:lstStyle/>
           <a:p>
             <a:r>
-              <a:rPr lang="en-US" b="1" u="sng" dirty="0" smtClean="0">
+              <a:rPr lang="en-US" b="1" u="sng" dirty="0">
                 <a:solidFill>
                   <a:srgbClr val="0070C0"/>
                 </a:solidFill>
@@ -7525,19 +7466,19 @@
             </a:r>
           </a:p>
           <a:p>
-            <a:endParaRPr lang="en-US" b="1" i="1" dirty="0" smtClean="0"/>
+            <a:endParaRPr lang="en-US" b="1" i="1" dirty="0"/>
           </a:p>
           <a:p>
             <a:pPr marL="342900" indent="-342900"/>
             <a:r>
-              <a:rPr lang="en-US" dirty="0" smtClean="0"/>
+              <a:rPr lang="en-US" dirty="0"/>
               <a:t>Look at each client of the object.  Almost invariably, you’ll find clients accessing the fields and manipulating the results, when the class could do it for them. </a:t>
             </a:r>
           </a:p>
           <a:p>
             <a:pPr marL="442913" lvl="1"/>
             <a:r>
-              <a:rPr lang="en-US" dirty="0" smtClean="0">
+              <a:rPr lang="en-US" dirty="0">
                 <a:solidFill>
                   <a:srgbClr val="FF0000"/>
                 </a:solidFill>
@@ -7548,11 +7489,11 @@
           <a:p>
             <a:pPr marL="442913" lvl="1" indent="14288"/>
             <a:r>
-              <a:rPr lang="en-US" dirty="0" smtClean="0"/>
+              <a:rPr lang="en-US" dirty="0"/>
               <a:t>On the client, use </a:t>
             </a:r>
             <a:r>
-              <a:rPr lang="en-US" b="1" i="1" dirty="0" smtClean="0">
+              <a:rPr lang="en-US" b="1" i="1" dirty="0">
                 <a:solidFill>
                   <a:srgbClr val="0070C0"/>
                 </a:solidFill>
@@ -7560,15 +7501,15 @@
               <a:t>Extract Method</a:t>
             </a:r>
             <a:r>
-              <a:rPr lang="en-US" i="1" dirty="0" smtClean="0"/>
+              <a:rPr lang="en-US" i="1" dirty="0"/>
               <a:t> to pull out the class-related code, </a:t>
             </a:r>
             <a:r>
-              <a:rPr lang="en-US" dirty="0" smtClean="0"/>
+              <a:rPr lang="en-US" dirty="0"/>
               <a:t>then </a:t>
             </a:r>
             <a:r>
-              <a:rPr lang="en-US" b="1" i="1" dirty="0" smtClean="0">
+              <a:rPr lang="en-US" b="1" i="1" dirty="0">
                 <a:solidFill>
                   <a:srgbClr val="0070C0"/>
                 </a:solidFill>
@@ -7576,7 +7517,7 @@
               <a:t>Move Method </a:t>
             </a:r>
             <a:r>
-              <a:rPr lang="en-US" i="1" dirty="0" smtClean="0"/>
+              <a:rPr lang="en-US" i="1" dirty="0"/>
               <a:t>to put it over on the class.</a:t>
             </a:r>
           </a:p>
@@ -7587,13 +7528,6 @@
   <p:clrMapOvr>
     <a:masterClrMapping/>
   </p:clrMapOvr>
-  <p:timing>
-    <p:tnLst>
-      <p:par>
-        <p:cTn id="1" dur="indefinite" restart="never" nodeType="tmRoot"/>
-      </p:par>
-    </p:tnLst>
-  </p:timing>
 </p:sld>
 </file>
 
@@ -7630,10 +7564,10 @@
           <a:lstStyle/>
           <a:p>
             <a:r>
-              <a:rPr lang="en-US" dirty="0" smtClean="0"/>
+              <a:rPr lang="en-US" dirty="0"/>
               <a:t>Data Class/Container</a:t>
             </a:r>
-            <a:endParaRPr lang="el-GR" dirty="0" smtClean="0"/>
+            <a:endParaRPr lang="el-GR" dirty="0"/>
           </a:p>
         </p:txBody>
       </p:sp>
@@ -7659,7 +7593,7 @@
           <a:lstStyle/>
           <a:p>
             <a:r>
-              <a:rPr lang="en-US" b="1" u="sng" dirty="0" smtClean="0">
+              <a:rPr lang="en-US" b="1" u="sng" dirty="0">
                 <a:solidFill>
                   <a:srgbClr val="0070C0"/>
                 </a:solidFill>
@@ -7668,16 +7602,16 @@
             </a:r>
           </a:p>
           <a:p>
-            <a:endParaRPr lang="en-US" b="1" i="1" dirty="0" smtClean="0"/>
+            <a:endParaRPr lang="en-US" b="1" i="1" dirty="0"/>
           </a:p>
           <a:p>
             <a:pPr marL="442913" lvl="1" indent="-442913"/>
             <a:r>
-              <a:rPr lang="en-US" dirty="0" smtClean="0"/>
+              <a:rPr lang="en-US" dirty="0"/>
               <a:t>After doing this a while, you may find that you have several similar methods on the class. Use </a:t>
             </a:r>
             <a:r>
-              <a:rPr lang="en-US" i="1" dirty="0" smtClean="0">
+              <a:rPr lang="en-US" i="1" dirty="0">
                 <a:solidFill>
                   <a:srgbClr val="0070C0"/>
                 </a:solidFill>
@@ -7685,7 +7619,7 @@
               <a:t>Rename Method, Extract Method, </a:t>
             </a:r>
             <a:r>
-              <a:rPr lang="en-US" b="1" i="1" dirty="0" smtClean="0">
+              <a:rPr lang="en-US" b="1" i="1" dirty="0">
                 <a:solidFill>
                   <a:srgbClr val="0070C0"/>
                 </a:solidFill>
@@ -7693,13 +7627,13 @@
               <a:t>Add Parameter, Remove Parameter</a:t>
             </a:r>
             <a:r>
-              <a:rPr lang="en-US" i="1" dirty="0" smtClean="0"/>
+              <a:rPr lang="en-US" i="1" dirty="0"/>
               <a:t>, etc. to harmonize signatures and remove duplication.</a:t>
             </a:r>
           </a:p>
           <a:p>
             <a:pPr marL="442913" lvl="1" indent="-442913"/>
-            <a:endParaRPr lang="en-US" i="1" dirty="0" smtClean="0"/>
+            <a:endParaRPr lang="en-US" i="1" dirty="0"/>
           </a:p>
         </p:txBody>
       </p:sp>
@@ -7708,13 +7642,6 @@
   <p:clrMapOvr>
     <a:masterClrMapping/>
   </p:clrMapOvr>
-  <p:timing>
-    <p:tnLst>
-      <p:par>
-        <p:cTn id="1" dur="indefinite" restart="never" nodeType="tmRoot"/>
-      </p:par>
-    </p:tnLst>
-  </p:timing>
 </p:sld>
 </file>
 
@@ -7751,10 +7678,9 @@
           <a:lstStyle/>
           <a:p>
             <a:r>
-              <a:rPr lang="en-US" dirty="0" smtClean="0"/>
+              <a:rPr lang="en-US" dirty="0"/>
               <a:t>Data Clump</a:t>
             </a:r>
-            <a:endParaRPr lang="en-US" dirty="0"/>
           </a:p>
         </p:txBody>
       </p:sp>
@@ -7818,10 +7744,10 @@
           <a:lstStyle/>
           <a:p>
             <a:r>
-              <a:rPr lang="en-US" dirty="0" smtClean="0"/>
+              <a:rPr lang="en-US" dirty="0"/>
               <a:t>Data Clump</a:t>
             </a:r>
-            <a:endParaRPr lang="el-GR" dirty="0" smtClean="0"/>
+            <a:endParaRPr lang="el-GR" dirty="0"/>
           </a:p>
         </p:txBody>
       </p:sp>
@@ -7847,7 +7773,7 @@
           <a:lstStyle/>
           <a:p>
             <a:r>
-              <a:rPr lang="en-US" b="1" u="sng" dirty="0" smtClean="0">
+              <a:rPr lang="en-US" b="1" u="sng" dirty="0">
                 <a:solidFill>
                   <a:srgbClr val="0070C0"/>
                 </a:solidFill>
@@ -7856,16 +7782,16 @@
             </a:r>
           </a:p>
           <a:p>
-            <a:endParaRPr lang="en-US" b="1" dirty="0" smtClean="0"/>
+            <a:endParaRPr lang="en-US" b="1" dirty="0"/>
           </a:p>
           <a:p>
             <a:pPr algn="just"/>
             <a:r>
-              <a:rPr lang="en-US" dirty="0" smtClean="0"/>
+              <a:rPr lang="en-US" dirty="0"/>
               <a:t>The </a:t>
             </a:r>
             <a:r>
-              <a:rPr lang="en-US" dirty="0" smtClean="0">
+              <a:rPr lang="en-US" dirty="0">
                 <a:solidFill>
                   <a:srgbClr val="FF0000"/>
                 </a:solidFill>
@@ -7873,11 +7799,11 @@
               <a:t>same two or three items</a:t>
             </a:r>
             <a:r>
-              <a:rPr lang="en-US" dirty="0" smtClean="0"/>
+              <a:rPr lang="en-US" dirty="0"/>
               <a:t> frequently </a:t>
             </a:r>
             <a:r>
-              <a:rPr lang="en-US" dirty="0" smtClean="0">
+              <a:rPr lang="en-US" dirty="0">
                 <a:solidFill>
                   <a:srgbClr val="FF0000"/>
                 </a:solidFill>
@@ -7885,11 +7811,11 @@
               <a:t>appear together </a:t>
             </a:r>
             <a:r>
-              <a:rPr lang="en-US" dirty="0" smtClean="0"/>
+              <a:rPr lang="en-US" dirty="0"/>
               <a:t>in </a:t>
             </a:r>
             <a:r>
-              <a:rPr lang="en-US" u="sng" dirty="0" smtClean="0">
+              <a:rPr lang="en-US" u="sng" dirty="0">
                 <a:solidFill>
                   <a:srgbClr val="FF0000"/>
                 </a:solidFill>
@@ -7897,11 +7823,11 @@
               <a:t>classes</a:t>
             </a:r>
             <a:r>
-              <a:rPr lang="en-US" dirty="0" smtClean="0"/>
+              <a:rPr lang="en-US" dirty="0"/>
               <a:t> and </a:t>
             </a:r>
             <a:r>
-              <a:rPr lang="en-US" u="sng" dirty="0" smtClean="0">
+              <a:rPr lang="en-US" u="sng" dirty="0">
                 <a:solidFill>
                   <a:srgbClr val="FF0000"/>
                 </a:solidFill>
@@ -7909,11 +7835,11 @@
               <a:t>parameter</a:t>
             </a:r>
             <a:r>
-              <a:rPr lang="en-US" u="sng" dirty="0" smtClean="0"/>
+              <a:rPr lang="en-US" u="sng" dirty="0"/>
               <a:t> </a:t>
             </a:r>
             <a:r>
-              <a:rPr lang="en-US" u="sng" dirty="0" smtClean="0">
+              <a:rPr lang="en-US" u="sng" dirty="0">
                 <a:solidFill>
                   <a:srgbClr val="FF0000"/>
                 </a:solidFill>
@@ -7921,27 +7847,27 @@
               <a:t>lists</a:t>
             </a:r>
             <a:r>
-              <a:rPr lang="en-US" dirty="0" smtClean="0"/>
+              <a:rPr lang="en-US" dirty="0"/>
               <a:t>.</a:t>
             </a:r>
           </a:p>
           <a:p>
             <a:r>
-              <a:rPr lang="en-US" dirty="0" smtClean="0"/>
+              <a:rPr lang="en-US" dirty="0"/>
               <a:t>You also get a whiff of this when people declare some fields, then methods that work with those fields, then more fields and more methods, etc. (That is, there are groups of fields and methods together within the class.)</a:t>
             </a:r>
           </a:p>
           <a:p>
-            <a:endParaRPr lang="en-US" dirty="0" smtClean="0"/>
+            <a:endParaRPr lang="en-US" dirty="0"/>
           </a:p>
           <a:p>
             <a:pPr algn="just"/>
             <a:r>
-              <a:rPr lang="en-US" dirty="0" smtClean="0"/>
+              <a:rPr lang="en-US" dirty="0"/>
               <a:t>You may </a:t>
             </a:r>
             <a:r>
-              <a:rPr lang="en-US" b="1" dirty="0" smtClean="0">
+              <a:rPr lang="en-US" b="1" dirty="0">
                 <a:solidFill>
                   <a:srgbClr val="FF0000"/>
                 </a:solidFill>
@@ -7949,11 +7875,11 @@
               <a:t>see groups of field/parameter names </a:t>
             </a:r>
             <a:r>
-              <a:rPr lang="en-US" dirty="0" smtClean="0"/>
+              <a:rPr lang="en-US" dirty="0"/>
               <a:t>that start or end with </a:t>
             </a:r>
             <a:r>
-              <a:rPr lang="en-US" b="1" dirty="0" smtClean="0">
+              <a:rPr lang="en-US" b="1" dirty="0">
                 <a:solidFill>
                   <a:srgbClr val="FF0000"/>
                 </a:solidFill>
@@ -7961,16 +7887,16 @@
               <a:t>similar substrings</a:t>
             </a:r>
             <a:r>
-              <a:rPr lang="en-US" dirty="0" smtClean="0"/>
+              <a:rPr lang="en-US" dirty="0"/>
               <a:t>.</a:t>
             </a:r>
           </a:p>
           <a:p>
-            <a:endParaRPr lang="en-US" b="1" dirty="0" smtClean="0"/>
-          </a:p>
-          <a:p>
-            <a:r>
-              <a:rPr lang="en-US" b="1" u="sng" dirty="0" smtClean="0">
+            <a:endParaRPr lang="en-US" b="1" dirty="0"/>
+          </a:p>
+          <a:p>
+            <a:r>
+              <a:rPr lang="en-US" b="1" u="sng" dirty="0">
                 <a:solidFill>
                   <a:srgbClr val="0070C0"/>
                 </a:solidFill>
@@ -7979,15 +7905,15 @@
             </a:r>
           </a:p>
           <a:p>
-            <a:endParaRPr lang="en-US" dirty="0" smtClean="0"/>
-          </a:p>
-          <a:p>
-            <a:r>
-              <a:rPr lang="en-US" dirty="0" smtClean="0"/>
+            <a:endParaRPr lang="en-US" dirty="0"/>
+          </a:p>
+          <a:p>
+            <a:r>
+              <a:rPr lang="en-US" dirty="0"/>
               <a:t>The values are typically </a:t>
             </a:r>
             <a:r>
-              <a:rPr lang="en-US" dirty="0" smtClean="0">
+              <a:rPr lang="en-US" dirty="0">
                 <a:solidFill>
                   <a:srgbClr val="0070C0"/>
                 </a:solidFill>
@@ -7995,11 +7921,11 @@
               <a:t>part of some other entity</a:t>
             </a:r>
             <a:r>
-              <a:rPr lang="en-US" dirty="0" smtClean="0"/>
+              <a:rPr lang="en-US" dirty="0"/>
               <a:t>, but no one has yet had the insight to realize that there’s a </a:t>
             </a:r>
             <a:r>
-              <a:rPr lang="en-US" b="1" dirty="0" smtClean="0">
+              <a:rPr lang="en-US" b="1" dirty="0">
                 <a:solidFill>
                   <a:srgbClr val="0070C0"/>
                 </a:solidFill>
@@ -8007,7 +7933,7 @@
               <a:t>missing class</a:t>
             </a:r>
             <a:r>
-              <a:rPr lang="en-US" dirty="0" smtClean="0"/>
+              <a:rPr lang="en-US" dirty="0"/>
               <a:t>. Or sometimes, people know the object is missing, but think it’s too small or unimportant to stand alone.</a:t>
             </a:r>
           </a:p>
@@ -8018,13 +7944,6 @@
   <p:clrMapOvr>
     <a:masterClrMapping/>
   </p:clrMapOvr>
-  <p:timing>
-    <p:tnLst>
-      <p:par>
-        <p:cTn id="1" dur="indefinite" restart="never" nodeType="tmRoot"/>
-      </p:par>
-    </p:tnLst>
-  </p:timing>
 </p:sld>
 </file>
 
@@ -8061,10 +7980,10 @@
           <a:lstStyle/>
           <a:p>
             <a:r>
-              <a:rPr lang="en-US" dirty="0" smtClean="0"/>
+              <a:rPr lang="en-US" dirty="0"/>
               <a:t>Data Clump</a:t>
             </a:r>
-            <a:endParaRPr lang="el-GR" dirty="0" smtClean="0"/>
+            <a:endParaRPr lang="el-GR" dirty="0"/>
           </a:p>
         </p:txBody>
       </p:sp>
@@ -8090,7 +8009,7 @@
           <a:lstStyle/>
           <a:p>
             <a:r>
-              <a:rPr lang="en-US" b="1" u="sng" dirty="0" smtClean="0">
+              <a:rPr lang="en-US" b="1" u="sng" dirty="0">
                 <a:solidFill>
                   <a:srgbClr val="0070C0"/>
                 </a:solidFill>
@@ -8099,7 +8018,7 @@
             </a:r>
           </a:p>
           <a:p>
-            <a:endParaRPr lang="en-US" b="1" dirty="0" smtClean="0"/>
+            <a:endParaRPr lang="en-US" b="1" dirty="0"/>
           </a:p>
           <a:p>
             <a:pPr marL="342900" indent="-342900">
@@ -8107,11 +8026,11 @@
               <a:buAutoNum type="arabicPeriod"/>
             </a:pPr>
             <a:r>
-              <a:rPr lang="en-US" dirty="0" smtClean="0"/>
+              <a:rPr lang="en-US" dirty="0"/>
               <a:t>If the values are </a:t>
             </a:r>
             <a:r>
-              <a:rPr lang="en-US" dirty="0" smtClean="0">
+              <a:rPr lang="en-US" dirty="0">
                 <a:solidFill>
                   <a:srgbClr val="0070C0"/>
                 </a:solidFill>
@@ -8119,11 +8038,11 @@
               <a:t>fields</a:t>
             </a:r>
             <a:r>
-              <a:rPr lang="en-US" dirty="0" smtClean="0"/>
+              <a:rPr lang="en-US" dirty="0"/>
               <a:t> in a class, use </a:t>
             </a:r>
             <a:r>
-              <a:rPr lang="en-US" i="1" dirty="0" smtClean="0">
+              <a:rPr lang="en-US" i="1" dirty="0">
                 <a:solidFill>
                   <a:srgbClr val="0070C0"/>
                 </a:solidFill>
@@ -8131,7 +8050,7 @@
               <a:t>Extract Class</a:t>
             </a:r>
             <a:r>
-              <a:rPr lang="en-US" i="1" dirty="0" smtClean="0"/>
+              <a:rPr lang="en-US" i="1" dirty="0"/>
               <a:t> to pull them into a new class.</a:t>
             </a:r>
           </a:p>
@@ -8141,11 +8060,11 @@
               <a:buAutoNum type="arabicPeriod"/>
             </a:pPr>
             <a:r>
-              <a:rPr lang="en-US" dirty="0" smtClean="0"/>
+              <a:rPr lang="en-US" dirty="0"/>
               <a:t>If the values are together in </a:t>
             </a:r>
             <a:r>
-              <a:rPr lang="en-US" dirty="0" smtClean="0">
+              <a:rPr lang="en-US" dirty="0">
                 <a:solidFill>
                   <a:srgbClr val="0070C0"/>
                 </a:solidFill>
@@ -8153,11 +8072,11 @@
               <a:t>method calls</a:t>
             </a:r>
             <a:r>
-              <a:rPr lang="en-US" dirty="0" smtClean="0"/>
+              <a:rPr lang="en-US" dirty="0"/>
               <a:t>, </a:t>
             </a:r>
             <a:r>
-              <a:rPr lang="en-US" i="1" dirty="0" smtClean="0">
+              <a:rPr lang="en-US" i="1" dirty="0">
                 <a:solidFill>
                   <a:srgbClr val="0070C0"/>
                 </a:solidFill>
@@ -8165,11 +8084,11 @@
               <a:t>Introduce Parameter Object</a:t>
             </a:r>
             <a:r>
-              <a:rPr lang="en-US" i="1" dirty="0" smtClean="0"/>
+              <a:rPr lang="en-US" i="1" dirty="0"/>
               <a:t> to extract </a:t>
             </a:r>
             <a:r>
-              <a:rPr lang="en-US" dirty="0" smtClean="0"/>
+              <a:rPr lang="en-US" dirty="0"/>
               <a:t>the new object.</a:t>
             </a:r>
           </a:p>
@@ -8180,13 +8099,6 @@
   <p:clrMapOvr>
     <a:masterClrMapping/>
   </p:clrMapOvr>
-  <p:timing>
-    <p:tnLst>
-      <p:par>
-        <p:cTn id="1" dur="indefinite" restart="never" nodeType="tmRoot"/>
-      </p:par>
-    </p:tnLst>
-  </p:timing>
 </p:sld>
 </file>
 
@@ -8223,10 +8135,10 @@
           <a:lstStyle/>
           <a:p>
             <a:r>
-              <a:rPr lang="en-US" dirty="0" smtClean="0"/>
+              <a:rPr lang="en-US" dirty="0"/>
               <a:t>Primitive Obsession</a:t>
             </a:r>
-            <a:endParaRPr lang="el-GR" dirty="0" smtClean="0"/>
+            <a:endParaRPr lang="el-GR" dirty="0"/>
           </a:p>
         </p:txBody>
       </p:sp>
@@ -8252,7 +8164,7 @@
           <a:lstStyle/>
           <a:p>
             <a:r>
-              <a:rPr lang="en-US" b="1" u="sng" dirty="0" smtClean="0">
+              <a:rPr lang="en-US" b="1" u="sng" dirty="0">
                 <a:solidFill>
                   <a:srgbClr val="0070C0"/>
                 </a:solidFill>
@@ -8261,7 +8173,7 @@
             </a:r>
           </a:p>
           <a:p>
-            <a:endParaRPr lang="en-US" b="1" u="sng" dirty="0" smtClean="0">
+            <a:endParaRPr lang="en-US" b="1" u="sng" dirty="0">
               <a:solidFill>
                 <a:srgbClr val="0070C0"/>
               </a:solidFill>
@@ -8269,13 +8181,13 @@
           </a:p>
           <a:p>
             <a:r>
-              <a:rPr lang="en-US" dirty="0" smtClean="0"/>
+              <a:rPr lang="en-US" dirty="0"/>
               <a:t>Look for: </a:t>
             </a:r>
           </a:p>
           <a:p>
             <a:r>
-              <a:rPr lang="en-US" b="1" dirty="0" smtClean="0">
+              <a:rPr lang="en-US" b="1" dirty="0">
                 <a:solidFill>
                   <a:srgbClr val="000099"/>
                 </a:solidFill>
@@ -8286,11 +8198,11 @@
           <a:p>
             <a:pPr lvl="1"/>
             <a:r>
-              <a:rPr lang="en-US" dirty="0" smtClean="0"/>
+              <a:rPr lang="en-US" dirty="0"/>
               <a:t>uses of the </a:t>
             </a:r>
             <a:r>
-              <a:rPr lang="en-US" dirty="0" smtClean="0">
+              <a:rPr lang="en-US" dirty="0">
                 <a:solidFill>
                   <a:srgbClr val="FF0000"/>
                 </a:solidFill>
@@ -8298,22 +8210,22 @@
               <a:t>primitive</a:t>
             </a:r>
             <a:r>
-              <a:rPr lang="en-US" dirty="0" smtClean="0"/>
+              <a:rPr lang="en-US" dirty="0"/>
               <a:t> or near-primitive types (</a:t>
             </a:r>
             <a:r>
-              <a:rPr lang="en-US" dirty="0" err="1" smtClean="0"/>
+              <a:rPr lang="en-US" dirty="0" err="1"/>
               <a:t>int</a:t>
             </a:r>
             <a:r>
-              <a:rPr lang="en-US" dirty="0" smtClean="0"/>
+              <a:rPr lang="en-US" dirty="0"/>
               <a:t>, float, String, etc.)</a:t>
             </a:r>
           </a:p>
           <a:p>
             <a:pPr lvl="1"/>
             <a:r>
-              <a:rPr lang="en-US" dirty="0" smtClean="0">
+              <a:rPr lang="en-US" dirty="0">
                 <a:solidFill>
                   <a:srgbClr val="FF0000"/>
                 </a:solidFill>
@@ -8321,11 +8233,11 @@
               <a:t>constants</a:t>
             </a:r>
             <a:r>
-              <a:rPr lang="en-US" dirty="0" smtClean="0"/>
+              <a:rPr lang="en-US" dirty="0"/>
               <a:t> and </a:t>
             </a:r>
             <a:r>
-              <a:rPr lang="en-US" dirty="0" smtClean="0">
+              <a:rPr lang="en-US" dirty="0">
                 <a:solidFill>
                   <a:srgbClr val="FF0000"/>
                 </a:solidFill>
@@ -8333,14 +8245,14 @@
               <a:t>enumerations</a:t>
             </a:r>
             <a:r>
-              <a:rPr lang="en-US" dirty="0" smtClean="0"/>
+              <a:rPr lang="en-US" dirty="0"/>
               <a:t> representing small integers</a:t>
             </a:r>
           </a:p>
           <a:p>
             <a:pPr lvl="1"/>
             <a:r>
-              <a:rPr lang="en-US" dirty="0" smtClean="0">
+              <a:rPr lang="en-US" dirty="0">
                 <a:solidFill>
                   <a:srgbClr val="FF0000"/>
                 </a:solidFill>
@@ -8348,12 +8260,12 @@
               <a:t>string constants </a:t>
             </a:r>
             <a:r>
-              <a:rPr lang="en-US" dirty="0" smtClean="0"/>
+              <a:rPr lang="en-US" dirty="0"/>
               <a:t>representing field names</a:t>
             </a:r>
           </a:p>
           <a:p>
-            <a:endParaRPr lang="en-US" b="1" u="sng" dirty="0" smtClean="0">
+            <a:endParaRPr lang="en-US" b="1" u="sng" dirty="0">
               <a:solidFill>
                 <a:srgbClr val="0070C0"/>
               </a:solidFill>
@@ -8361,14 +8273,14 @@
           </a:p>
           <a:p>
             <a:r>
-              <a:rPr lang="en-US" b="1" u="sng" dirty="0" smtClean="0">
+              <a:rPr lang="en-US" b="1" u="sng" dirty="0">
                 <a:solidFill>
                   <a:srgbClr val="0070C0"/>
                 </a:solidFill>
               </a:rPr>
               <a:t>Causes (what kind of primitives can we have??)</a:t>
             </a:r>
-            <a:endParaRPr lang="en-US" b="1" i="1" u="sng" dirty="0" smtClean="0">
+            <a:endParaRPr lang="en-US" b="1" i="1" u="sng" dirty="0">
               <a:solidFill>
                 <a:srgbClr val="0070C0"/>
               </a:solidFill>
@@ -8376,7 +8288,7 @@
           </a:p>
           <a:p>
             <a:r>
-              <a:rPr lang="en-US" i="1" dirty="0" smtClean="0">
+              <a:rPr lang="en-US" i="1" dirty="0">
                 <a:solidFill>
                   <a:srgbClr val="0070C0"/>
                 </a:solidFill>
@@ -8384,22 +8296,22 @@
               <a:t>Missing class:</a:t>
             </a:r>
             <a:r>
-              <a:rPr lang="en-US" i="1" dirty="0" smtClean="0"/>
+              <a:rPr lang="en-US" i="1" dirty="0"/>
               <a:t> Since almost all data must be in a primitive somewhere, it’s easy to</a:t>
             </a:r>
           </a:p>
           <a:p>
             <a:r>
-              <a:rPr lang="en-US" dirty="0" smtClean="0"/>
+              <a:rPr lang="en-US" dirty="0"/>
               <a:t>start with a primitive, and miss an opportunity to introduce a new object.</a:t>
             </a:r>
           </a:p>
           <a:p>
-            <a:endParaRPr lang="en-US" dirty="0" smtClean="0"/>
-          </a:p>
-          <a:p>
-            <a:r>
-              <a:rPr lang="en-US" i="1" dirty="0" smtClean="0">
+            <a:endParaRPr lang="en-US" dirty="0"/>
+          </a:p>
+          <a:p>
+            <a:r>
+              <a:rPr lang="en-US" i="1" dirty="0">
                 <a:solidFill>
                   <a:srgbClr val="0070C0"/>
                 </a:solidFill>
@@ -8407,7 +8319,7 @@
               <a:t>Simulated field </a:t>
             </a:r>
             <a:r>
-              <a:rPr lang="en-US" i="1" dirty="0" err="1" smtClean="0">
+              <a:rPr lang="en-US" i="1" dirty="0" err="1">
                 <a:solidFill>
                   <a:srgbClr val="0070C0"/>
                 </a:solidFill>
@@ -8415,11 +8327,11 @@
               <a:t>accessors</a:t>
             </a:r>
             <a:r>
-              <a:rPr lang="en-US" i="1" dirty="0" smtClean="0"/>
+              <a:rPr lang="en-US" i="1" dirty="0"/>
               <a:t>: Sometimes, a primitive is </a:t>
             </a:r>
             <a:r>
-              <a:rPr lang="en-US" b="1" i="1" dirty="0" smtClean="0">
+              <a:rPr lang="en-US" b="1" i="1" dirty="0">
                 <a:solidFill>
                   <a:srgbClr val="FF0000"/>
                 </a:solidFill>
@@ -8427,15 +8339,15 @@
               <a:t>used as an index</a:t>
             </a:r>
             <a:r>
-              <a:rPr lang="en-US" i="1" dirty="0" smtClean="0"/>
+              <a:rPr lang="en-US" i="1" dirty="0"/>
               <a:t>, to provide </a:t>
             </a:r>
             <a:r>
-              <a:rPr lang="en-US" dirty="0" smtClean="0"/>
+              <a:rPr lang="en-US" dirty="0"/>
               <a:t>access to </a:t>
             </a:r>
             <a:r>
-              <a:rPr lang="en-US" b="1" u="sng" dirty="0" smtClean="0">
+              <a:rPr lang="en-US" b="1" u="sng" dirty="0">
                 <a:solidFill>
                   <a:srgbClr val="FF0000"/>
                 </a:solidFill>
@@ -8443,11 +8355,11 @@
               <a:t>pseudo-fields</a:t>
             </a:r>
             <a:r>
-              <a:rPr lang="en-US" dirty="0" smtClean="0"/>
+              <a:rPr lang="en-US" dirty="0"/>
               <a:t> in an </a:t>
             </a:r>
             <a:r>
-              <a:rPr lang="en-US" b="1" dirty="0" smtClean="0">
+              <a:rPr lang="en-US" b="1" dirty="0">
                 <a:solidFill>
                   <a:srgbClr val="C00000"/>
                 </a:solidFill>
@@ -8455,11 +8367,11 @@
               <a:t>array</a:t>
             </a:r>
             <a:r>
-              <a:rPr lang="en-US" dirty="0" smtClean="0"/>
+              <a:rPr lang="en-US" dirty="0"/>
               <a:t>.  Strings are occasionally used this way with </a:t>
             </a:r>
             <a:r>
-              <a:rPr lang="en-US" dirty="0" err="1" smtClean="0">
+              <a:rPr lang="en-US" dirty="0" err="1">
                 <a:solidFill>
                   <a:srgbClr val="FF0000"/>
                 </a:solidFill>
@@ -8467,11 +8379,11 @@
               <a:t>HashTables</a:t>
             </a:r>
             <a:r>
-              <a:rPr lang="en-US" dirty="0" smtClean="0"/>
+              <a:rPr lang="en-US" dirty="0"/>
               <a:t> or </a:t>
             </a:r>
             <a:r>
-              <a:rPr lang="en-US" dirty="0" smtClean="0">
+              <a:rPr lang="en-US" dirty="0">
                 <a:solidFill>
                   <a:srgbClr val="FF0000"/>
                 </a:solidFill>
@@ -8479,16 +8391,16 @@
               <a:t>Maps</a:t>
             </a:r>
             <a:r>
-              <a:rPr lang="en-US" dirty="0" smtClean="0"/>
+              <a:rPr lang="en-US" dirty="0"/>
               <a:t>.</a:t>
             </a:r>
           </a:p>
           <a:p>
-            <a:endParaRPr lang="en-US" i="1" dirty="0" smtClean="0"/>
-          </a:p>
-          <a:p>
-            <a:r>
-              <a:rPr lang="en-US" i="1" dirty="0" smtClean="0">
+            <a:endParaRPr lang="en-US" i="1" dirty="0"/>
+          </a:p>
+          <a:p>
+            <a:r>
+              <a:rPr lang="en-US" i="1" dirty="0">
                 <a:solidFill>
                   <a:srgbClr val="0070C0"/>
                 </a:solidFill>
@@ -8496,11 +8408,11 @@
               <a:t>Type codes</a:t>
             </a:r>
             <a:r>
-              <a:rPr lang="en-US" i="1" dirty="0" smtClean="0"/>
+              <a:rPr lang="en-US" i="1" dirty="0"/>
               <a:t>: instead of having different sub-classes of objects we have a class field whose values </a:t>
             </a:r>
             <a:r>
-              <a:rPr lang="en-US" b="1" i="1" dirty="0" smtClean="0">
+              <a:rPr lang="en-US" b="1" i="1" dirty="0">
                 <a:solidFill>
                   <a:srgbClr val="FF0000"/>
                 </a:solidFill>
@@ -8508,12 +8420,12 @@
               <a:t>distinguish different kinds of objects</a:t>
             </a:r>
             <a:r>
-              <a:rPr lang="en-US" i="1" dirty="0" smtClean="0"/>
+              <a:rPr lang="en-US" i="1" dirty="0"/>
               <a:t>. That belong to the class  </a:t>
             </a:r>
           </a:p>
           <a:p>
-            <a:endParaRPr lang="en-US" dirty="0" smtClean="0"/>
+            <a:endParaRPr lang="en-US" dirty="0"/>
           </a:p>
         </p:txBody>
       </p:sp>
@@ -8522,13 +8434,6 @@
   <p:clrMapOvr>
     <a:masterClrMapping/>
   </p:clrMapOvr>
-  <p:timing>
-    <p:tnLst>
-      <p:par>
-        <p:cTn id="1" dur="indefinite" restart="never" nodeType="tmRoot"/>
-      </p:par>
-    </p:tnLst>
-  </p:timing>
 </p:sld>
 </file>
 
@@ -8565,10 +8470,10 @@
           <a:lstStyle/>
           <a:p>
             <a:r>
-              <a:rPr lang="en-US" dirty="0" smtClean="0"/>
+              <a:rPr lang="en-US" dirty="0"/>
               <a:t>Primitive Obsession</a:t>
             </a:r>
-            <a:endParaRPr lang="el-GR" dirty="0" smtClean="0"/>
+            <a:endParaRPr lang="el-GR" dirty="0"/>
           </a:p>
         </p:txBody>
       </p:sp>
@@ -8594,7 +8499,7 @@
           <a:lstStyle/>
           <a:p>
             <a:r>
-              <a:rPr lang="en-US" b="1" u="sng" dirty="0" smtClean="0">
+              <a:rPr lang="en-US" b="1" u="sng" dirty="0">
                 <a:solidFill>
                   <a:srgbClr val="0070C0"/>
                 </a:solidFill>
@@ -8603,24 +8508,24 @@
             </a:r>
           </a:p>
           <a:p>
-            <a:endParaRPr lang="en-US" b="1" dirty="0" smtClean="0"/>
+            <a:endParaRPr lang="en-US" b="1" dirty="0"/>
           </a:p>
           <a:p>
             <a:pPr marL="342900" indent="-342900"/>
             <a:r>
-              <a:rPr lang="en-US" dirty="0" smtClean="0">
+              <a:rPr lang="en-US" dirty="0">
                 <a:solidFill>
                   <a:srgbClr val="0070C0"/>
                 </a:solidFill>
               </a:rPr>
               <a:t>For missing classes:</a:t>
             </a:r>
-            <a:endParaRPr lang="en-US" i="1" dirty="0" smtClean="0"/>
+            <a:endParaRPr lang="en-US" i="1" dirty="0"/>
           </a:p>
           <a:p>
             <a:pPr lvl="1"/>
             <a:r>
-              <a:rPr lang="en-US" b="1" i="1" dirty="0" smtClean="0">
+              <a:rPr lang="en-US" b="1" i="1" dirty="0">
                 <a:solidFill>
                   <a:srgbClr val="0070C0"/>
                 </a:solidFill>
@@ -8628,12 +8533,12 @@
               <a:t>Replace Data Value with Object </a:t>
             </a:r>
             <a:r>
-              <a:rPr lang="en-US" i="1" dirty="0" smtClean="0"/>
+              <a:rPr lang="en-US" i="1" dirty="0"/>
               <a:t>to make data values “first-class.”</a:t>
             </a:r>
           </a:p>
           <a:p>
-            <a:endParaRPr lang="en-US" i="1" dirty="0" smtClean="0"/>
+            <a:endParaRPr lang="en-US" i="1" dirty="0"/>
           </a:p>
           <a:p>
             <a:endParaRPr lang="en-US" b="1" dirty="0">
@@ -8649,13 +8554,6 @@
   <p:clrMapOvr>
     <a:masterClrMapping/>
   </p:clrMapOvr>
-  <p:timing>
-    <p:tnLst>
-      <p:par>
-        <p:cTn id="1" dur="indefinite" restart="never" nodeType="tmRoot"/>
-      </p:par>
-    </p:tnLst>
-  </p:timing>
 </p:sld>
 </file>
 
@@ -8692,10 +8590,10 @@
           <a:lstStyle/>
           <a:p>
             <a:r>
-              <a:rPr lang="en-US" dirty="0" smtClean="0"/>
+              <a:rPr lang="en-US" dirty="0"/>
               <a:t>Replace Data Value with Object </a:t>
             </a:r>
-            <a:endParaRPr lang="el-GR" dirty="0" smtClean="0"/>
+            <a:endParaRPr lang="el-GR" dirty="0"/>
           </a:p>
         </p:txBody>
       </p:sp>
@@ -8818,13 +8716,6 @@
   <p:clrMapOvr>
     <a:masterClrMapping/>
   </p:clrMapOvr>
-  <p:timing>
-    <p:tnLst>
-      <p:par>
-        <p:cTn id="1" dur="indefinite" restart="never" nodeType="tmRoot"/>
-      </p:par>
-    </p:tnLst>
-  </p:timing>
 </p:sld>
 </file>
 
@@ -8861,10 +8752,10 @@
           <a:lstStyle/>
           <a:p>
             <a:r>
-              <a:rPr lang="en-US" dirty="0" smtClean="0"/>
+              <a:rPr lang="en-US" dirty="0"/>
               <a:t>Primitive Obsession</a:t>
             </a:r>
-            <a:endParaRPr lang="el-GR" dirty="0" smtClean="0"/>
+            <a:endParaRPr lang="el-GR" dirty="0"/>
           </a:p>
         </p:txBody>
       </p:sp>
@@ -8890,7 +8781,7 @@
           <a:lstStyle/>
           <a:p>
             <a:r>
-              <a:rPr lang="en-US" b="1" u="sng" dirty="0" smtClean="0">
+              <a:rPr lang="en-US" b="1" u="sng" dirty="0">
                 <a:solidFill>
                   <a:srgbClr val="0070C0"/>
                 </a:solidFill>
@@ -8899,12 +8790,12 @@
             </a:r>
           </a:p>
           <a:p>
-            <a:endParaRPr lang="en-US" b="1" dirty="0" smtClean="0"/>
+            <a:endParaRPr lang="en-US" b="1" dirty="0"/>
           </a:p>
           <a:p>
             <a:pPr marL="342900" indent="-342900"/>
             <a:r>
-              <a:rPr lang="en-US" dirty="0" smtClean="0">
+              <a:rPr lang="en-US" dirty="0">
                 <a:solidFill>
                   <a:srgbClr val="0070C0"/>
                 </a:solidFill>
@@ -8912,7 +8803,7 @@
               <a:t>For simulated field </a:t>
             </a:r>
             <a:r>
-              <a:rPr lang="en-US" dirty="0" err="1" smtClean="0">
+              <a:rPr lang="en-US" dirty="0" err="1">
                 <a:solidFill>
                   <a:srgbClr val="0070C0"/>
                 </a:solidFill>
@@ -8920,7 +8811,7 @@
               <a:t>accessors</a:t>
             </a:r>
             <a:r>
-              <a:rPr lang="en-US" dirty="0" smtClean="0">
+              <a:rPr lang="en-US" dirty="0">
                 <a:solidFill>
                   <a:srgbClr val="0070C0"/>
                 </a:solidFill>
@@ -8931,11 +8822,11 @@
           <a:p>
             <a:pPr lvl="1"/>
             <a:r>
-              <a:rPr lang="en-US" dirty="0" smtClean="0"/>
+              <a:rPr lang="en-US" dirty="0"/>
               <a:t>If the primitives are indexes used to treat certain array elements as pseudo fields, </a:t>
             </a:r>
             <a:r>
-              <a:rPr lang="en-US" b="1" i="1" dirty="0" smtClean="0">
+              <a:rPr lang="en-US" b="1" i="1" dirty="0">
                 <a:solidFill>
                   <a:srgbClr val="0070C0"/>
                 </a:solidFill>
@@ -8943,12 +8834,12 @@
               <a:t>Replace Array with Object</a:t>
             </a:r>
             <a:r>
-              <a:rPr lang="en-US" i="1" dirty="0" smtClean="0"/>
+              <a:rPr lang="en-US" i="1" dirty="0"/>
               <a:t>.</a:t>
             </a:r>
           </a:p>
           <a:p>
-            <a:endParaRPr lang="en-US" i="1" dirty="0" smtClean="0"/>
+            <a:endParaRPr lang="en-US" i="1" dirty="0"/>
           </a:p>
           <a:p>
             <a:endParaRPr lang="en-US" b="1" dirty="0">
@@ -8965,13 +8856,6 @@
     <a:masterClrMapping/>
   </p:clrMapOvr>
   <p:transition/>
-  <p:timing>
-    <p:tnLst>
-      <p:par>
-        <p:cTn id="1" dur="indefinite" restart="never" nodeType="tmRoot"/>
-      </p:par>
-    </p:tnLst>
-  </p:timing>
 </p:sld>
 </file>
 
@@ -9008,10 +8892,10 @@
           <a:lstStyle/>
           <a:p>
             <a:r>
-              <a:rPr lang="en-US" dirty="0" smtClean="0"/>
+              <a:rPr lang="en-US" dirty="0"/>
               <a:t>Replace Array with Object</a:t>
             </a:r>
-            <a:endParaRPr lang="el-GR" dirty="0" smtClean="0"/>
+            <a:endParaRPr lang="el-GR" dirty="0"/>
           </a:p>
         </p:txBody>
       </p:sp>
@@ -9105,18 +8989,13 @@
           <a:p>
             <a:pPr algn="ctr"/>
             <a:r>
-              <a:rPr lang="en-US" b="1" dirty="0" smtClean="0">
+              <a:rPr lang="en-US" b="1" dirty="0">
                 <a:solidFill>
                   <a:srgbClr val="FF0000"/>
                 </a:solidFill>
               </a:rPr>
               <a:t>The primitives here are the array and the indexes</a:t>
             </a:r>
-            <a:endParaRPr lang="en-US" b="1" dirty="0">
-              <a:solidFill>
-                <a:srgbClr val="FF0000"/>
-              </a:solidFill>
-            </a:endParaRPr>
           </a:p>
         </p:txBody>
       </p:sp>
@@ -9126,13 +9005,6 @@
     <a:masterClrMapping/>
   </p:clrMapOvr>
   <p:transition/>
-  <p:timing>
-    <p:tnLst>
-      <p:par>
-        <p:cTn id="1" dur="indefinite" restart="never" nodeType="tmRoot"/>
-      </p:par>
-    </p:tnLst>
-  </p:timing>
 </p:sld>
 </file>
 
@@ -9169,10 +9041,10 @@
           <a:lstStyle/>
           <a:p>
             <a:r>
-              <a:rPr lang="en-US" dirty="0" smtClean="0"/>
+              <a:rPr lang="en-US" dirty="0"/>
               <a:t>Primitive Obsession</a:t>
             </a:r>
-            <a:endParaRPr lang="el-GR" dirty="0" smtClean="0"/>
+            <a:endParaRPr lang="el-GR" dirty="0"/>
           </a:p>
         </p:txBody>
       </p:sp>
@@ -9198,7 +9070,7 @@
           <a:lstStyle/>
           <a:p>
             <a:r>
-              <a:rPr lang="en-US" b="1" u="sng" dirty="0" smtClean="0">
+              <a:rPr lang="en-US" b="1" u="sng" dirty="0">
                 <a:solidFill>
                   <a:srgbClr val="0070C0"/>
                 </a:solidFill>
@@ -9207,12 +9079,12 @@
             </a:r>
           </a:p>
           <a:p>
-            <a:endParaRPr lang="en-US" b="1" dirty="0" smtClean="0"/>
+            <a:endParaRPr lang="en-US" b="1" dirty="0"/>
           </a:p>
           <a:p>
             <a:pPr marL="342900" indent="-342900"/>
             <a:r>
-              <a:rPr lang="en-US" dirty="0" smtClean="0">
+              <a:rPr lang="en-US" dirty="0">
                 <a:solidFill>
                   <a:srgbClr val="0070C0"/>
                 </a:solidFill>
@@ -9220,22 +9092,22 @@
               <a:t>For type codes</a:t>
             </a:r>
             <a:r>
-              <a:rPr lang="en-US" dirty="0" smtClean="0"/>
+              <a:rPr lang="en-US" dirty="0"/>
               <a:t>:.</a:t>
             </a:r>
           </a:p>
           <a:p>
             <a:pPr marL="800100" lvl="1" indent="-342900"/>
-            <a:endParaRPr lang="en-US" dirty="0" smtClean="0"/>
+            <a:endParaRPr lang="en-US" dirty="0"/>
           </a:p>
           <a:p>
             <a:pPr marL="800100" lvl="1" indent="-342900"/>
             <a:r>
-              <a:rPr lang="en-US" dirty="0" smtClean="0"/>
+              <a:rPr lang="en-US" dirty="0"/>
               <a:t>If </a:t>
             </a:r>
             <a:r>
-              <a:rPr lang="en-US" dirty="0" smtClean="0">
+              <a:rPr lang="en-US" dirty="0">
                 <a:solidFill>
                   <a:srgbClr val="0070C0"/>
                 </a:solidFill>
@@ -9243,11 +9115,11 @@
               <a:t>no behavior is conditional on the type code</a:t>
             </a:r>
             <a:r>
-              <a:rPr lang="en-US" dirty="0" smtClean="0"/>
+              <a:rPr lang="en-US" dirty="0"/>
               <a:t>, then it is more like an enumeration, so </a:t>
             </a:r>
             <a:r>
-              <a:rPr lang="en-US" b="1" i="1" dirty="0" smtClean="0">
+              <a:rPr lang="en-US" b="1" i="1" dirty="0">
                 <a:solidFill>
                   <a:srgbClr val="0070C0"/>
                 </a:solidFill>
@@ -9255,10 +9127,10 @@
               <a:t>Replace Type Code with Class</a:t>
             </a:r>
             <a:r>
-              <a:rPr lang="en-US" i="1" dirty="0" smtClean="0"/>
+              <a:rPr lang="en-US" i="1" dirty="0"/>
               <a:t>.</a:t>
             </a:r>
-            <a:endParaRPr lang="en-US" dirty="0" smtClean="0"/>
+            <a:endParaRPr lang="en-US" dirty="0"/>
           </a:p>
         </p:txBody>
       </p:sp>
@@ -9268,13 +9140,6 @@
     <a:masterClrMapping/>
   </p:clrMapOvr>
   <p:transition/>
-  <p:timing>
-    <p:tnLst>
-      <p:par>
-        <p:cTn id="1" dur="indefinite" restart="never" nodeType="tmRoot"/>
-      </p:par>
-    </p:tnLst>
-  </p:timing>
 </p:sld>
 </file>
 
@@ -9311,10 +9176,10 @@
           <a:lstStyle/>
           <a:p>
             <a:r>
-              <a:rPr lang="en-US" dirty="0" smtClean="0"/>
+              <a:rPr lang="en-US" dirty="0"/>
               <a:t>Replace Type Code with Class</a:t>
             </a:r>
-            <a:endParaRPr lang="el-GR" dirty="0" smtClean="0"/>
+            <a:endParaRPr lang="el-GR" dirty="0"/>
           </a:p>
         </p:txBody>
       </p:sp>
@@ -9390,13 +9255,6 @@
     <a:masterClrMapping/>
   </p:clrMapOvr>
   <p:transition/>
-  <p:timing>
-    <p:tnLst>
-      <p:par>
-        <p:cTn id="1" dur="indefinite" restart="never" nodeType="tmRoot"/>
-      </p:par>
-    </p:tnLst>
-  </p:timing>
 </p:sld>
 </file>
 

</xml_diff>